<commit_message>
Welle 3: VA03 kuratiertes Deck + 2 Schaubilder (Web/Admin/Workbook)
Co-Authored-By: Claude Fable 5 <noreply@anthropic.com>
</commit_message>
<xml_diff>
--- a/protected-downloads/praesentation/VA03.pptx
+++ b/protected-downloads/praesentation/VA03.pptx
@@ -13,6 +13,14 @@
     <p:sldId id="261" r:id="rId13"/>
     <p:sldId id="262" r:id="rId14"/>
     <p:sldId id="263" r:id="rId15"/>
+    <p:sldId id="264" r:id="rId16"/>
+    <p:sldId id="265" r:id="rId17"/>
+    <p:sldId id="266" r:id="rId18"/>
+    <p:sldId id="267" r:id="rId19"/>
+    <p:sldId id="268" r:id="rId20"/>
+    <p:sldId id="269" r:id="rId21"/>
+    <p:sldId id="270" r:id="rId22"/>
+    <p:sldId id="271" r:id="rId23"/>
   </p:sldIdLst>
   <p:sldSz cx="12188952" cy="6858000" type="screen4x3"/>
   <p:notesSz cx="6858000" cy="9144000"/>
@@ -579,7 +587,7 @@
           <a:lstStyle/>
           <a:p>
             <a:r>
-              <a:t>Siehe Trainerhandbuch (Sektion 3) für Moderationshinweise, Timing und erwartete Teilnehmerreaktionen.</a:t>
+              <a:t>Einstiegsfrage: „Welche Aufgabe erledigen Sie heute noch nicht im System?" Kurze Diskussion: Was passiert, wenn die Kollegin krank ist und die Notiz nirgends im System steht?</a:t>
             </a:r>
           </a:p>
         </p:txBody>
@@ -649,7 +657,7 @@
           <a:lstStyle/>
           <a:p>
             <a:r>
-              <a:t>Siehe Trainerhandbuch (Sektion 3) für Moderationshinweise, Timing und erwartete Teilnehmerreaktionen.</a:t>
+              <a:t>Kernbotschaft: ein Datenpunkt, ein Ort. Der gemeinsame Stand ist der eigentliche Wert des Systems.</a:t>
             </a:r>
           </a:p>
         </p:txBody>
@@ -719,27 +727,7 @@
           <a:lstStyle/>
           <a:p>
             <a:r>
-              <a:t>AB-2 Musterlösung (Trainer-Version)</a:t>
-            </a:r>
-          </a:p>
-          <a:p>
-            <a:r>
-              <a:t>1. Einstieg über Suche/Kundenstamm → Kunde „Metallbau Musterregion GmbH" → Engagement-/Kreditübersicht → Bereich Sicherheiten; ergänzend Dokumentenablage für den hinterlegten Vertrag.</a:t>
-            </a:r>
-          </a:p>
-          <a:p>
-            <a:r>
-              <a:t>2. „Aktuell" beurteilt sich über Vertragsdatum/Version und Übereinstimmung mit dem aktuellen Engagement (z. B. valutierter Kredit, bestellte Grundschuld). Liegt nur eine ältere Version vor → als offenen Punkt behandeln.</a:t>
-            </a:r>
-          </a:p>
-          <a:p>
-            <a:r>
-              <a:t>3. Rückmeldung an den Berater kurz und faktisch; Dokumentation als Vorgangsnotiz im System, nicht per E-Mail – so ist sie auffindbar und nachvollziehbar.</a:t>
-            </a:r>
-          </a:p>
-          <a:p>
-            <a:r>
-              <a:t>Trainer-Hinweis: Ziel ist das Prinzip „im System statt daneben". Wenn Teilnehmer sagen „per Zuruf geht das schneller", die Folgekosten sichtbar machen (Was passiert, wenn Sie krank sind und die Kollegin den Vorgang übernimmt?). Menüwege je Installation variieren – nicht den Klickpfad bewerten, sondern ob der richtige Funktionsbereich gewählt wurde.</a:t>
+              <a:t>DSGVO greifbar machen: eine Excel-Liste mit Kundennamen und Kreditbeträgen auf privatem Laufwerk oder USB-Stick ist ein meldepflichtiger Verstoß.</a:t>
             </a:r>
           </a:p>
         </p:txBody>
@@ -809,7 +797,297 @@
           <a:lstStyle/>
           <a:p>
             <a:r>
-              <a:t>Siehe Trainerhandbuch (Sektion 3) für Moderationshinweise, Timing und erwartete Teilnehmerreaktionen.</a:t>
+              <a:t>Erst zuordnen (AB-1), dann am System recherchieren (AB-2). Trainer beobachtet, ohne einzugreifen; nur bei Navigationsfragen kurz den Weg zeigen.</a:t>
+            </a:r>
+          </a:p>
+        </p:txBody>
+      </p:sp>
+      <p:sp>
+        <p:nvSpPr>
+          <p:cNvPr id="4" name="Slide Number Placeholder 3"/>
+          <p:cNvSpPr>
+            <a:spLocks noGrp="1"/>
+          </p:cNvSpPr>
+          <p:nvPr>
+            <p:ph type="sldNum" idx="5" sz="quarter"/>
+          </p:nvPr>
+        </p:nvSpPr>
+        <p:spPr/>
+      </p:sp>
+    </p:spTree>
+  </p:cSld>
+  <p:clrMapOvr>
+    <a:masterClrMapping/>
+  </p:clrMapOvr>
+</p:notes>
+</file>
+
+<file path=ppt/notesSlides/notesSlide6.xml><?xml version="1.0" encoding="utf-8"?>
+<p:notes xmlns:a="http://schemas.openxmlformats.org/drawingml/2006/main" xmlns:p="http://schemas.openxmlformats.org/presentationml/2006/main" xmlns:r="http://schemas.openxmlformats.org/officeDocument/2006/relationships">
+  <p:cSld>
+    <p:spTree>
+      <p:nvGrpSpPr>
+        <p:cNvPr id="1" name=""/>
+        <p:cNvGrpSpPr/>
+        <p:nvPr/>
+      </p:nvGrpSpPr>
+      <p:grpSpPr>
+        <a:xfrm>
+          <a:off x="0" y="0"/>
+          <a:ext cx="0" cy="0"/>
+          <a:chOff x="0" y="0"/>
+          <a:chExt cx="0" cy="0"/>
+        </a:xfrm>
+      </p:grpSpPr>
+      <p:sp>
+        <p:nvSpPr>
+          <p:cNvPr id="2" name="Slide Image Placeholder 1"/>
+          <p:cNvSpPr>
+            <a:spLocks noGrp="1"/>
+          </p:cNvSpPr>
+          <p:nvPr>
+            <p:ph type="sldImg" idx="2"/>
+          </p:nvPr>
+        </p:nvSpPr>
+        <p:spPr/>
+      </p:sp>
+      <p:sp>
+        <p:nvSpPr>
+          <p:cNvPr id="3" name="Notes Placeholder 2"/>
+          <p:cNvSpPr>
+            <a:spLocks noGrp="1"/>
+          </p:cNvSpPr>
+          <p:nvPr>
+            <p:ph type="body" idx="3" sz="quarter"/>
+          </p:nvPr>
+        </p:nvSpPr>
+        <p:spPr/>
+        <p:txBody>
+          <a:bodyPr/>
+          <a:lstStyle/>
+          <a:p>
+            <a:r>
+              <a:t>Revisionssicherheit testen lassen: nach dem Speichern der Vorgangsnotiz prüfen, ob der Text noch änderbar ist – das ist der Test für die eigene Installation.</a:t>
+            </a:r>
+          </a:p>
+        </p:txBody>
+      </p:sp>
+      <p:sp>
+        <p:nvSpPr>
+          <p:cNvPr id="4" name="Slide Number Placeholder 3"/>
+          <p:cNvSpPr>
+            <a:spLocks noGrp="1"/>
+          </p:cNvSpPr>
+          <p:nvPr>
+            <p:ph type="sldNum" idx="5" sz="quarter"/>
+          </p:nvPr>
+        </p:nvSpPr>
+        <p:spPr/>
+      </p:sp>
+    </p:spTree>
+  </p:cSld>
+  <p:clrMapOvr>
+    <a:masterClrMapping/>
+  </p:clrMapOvr>
+</p:notes>
+</file>
+
+<file path=ppt/notesSlides/notesSlide7.xml><?xml version="1.0" encoding="utf-8"?>
+<p:notes xmlns:a="http://schemas.openxmlformats.org/drawingml/2006/main" xmlns:p="http://schemas.openxmlformats.org/presentationml/2006/main" xmlns:r="http://schemas.openxmlformats.org/officeDocument/2006/relationships">
+  <p:cSld>
+    <p:spTree>
+      <p:nvGrpSpPr>
+        <p:cNvPr id="1" name=""/>
+        <p:cNvGrpSpPr/>
+        <p:nvPr/>
+      </p:nvGrpSpPr>
+      <p:grpSpPr>
+        <a:xfrm>
+          <a:off x="0" y="0"/>
+          <a:ext cx="0" cy="0"/>
+          <a:chOff x="0" y="0"/>
+          <a:chExt cx="0" cy="0"/>
+        </a:xfrm>
+      </p:grpSpPr>
+      <p:sp>
+        <p:nvSpPr>
+          <p:cNvPr id="2" name="Slide Image Placeholder 1"/>
+          <p:cNvSpPr>
+            <a:spLocks noGrp="1"/>
+          </p:cNvSpPr>
+          <p:nvPr>
+            <p:ph type="sldImg" idx="2"/>
+          </p:nvPr>
+        </p:nvSpPr>
+        <p:spPr/>
+      </p:sp>
+      <p:sp>
+        <p:nvSpPr>
+          <p:cNvPr id="3" name="Notes Placeholder 2"/>
+          <p:cNvSpPr>
+            <a:spLocks noGrp="1"/>
+          </p:cNvSpPr>
+          <p:nvPr>
+            <p:ph type="body" idx="3" sz="quarter"/>
+          </p:nvPr>
+        </p:nvSpPr>
+        <p:spPr/>
+        <p:txBody>
+          <a:bodyPr/>
+          <a:lstStyle/>
+          <a:p>
+            <a:r>
+              <a:t>AB-2 Musterlösung (Trainer-Version)</a:t>
+            </a:r>
+          </a:p>
+          <a:p>
+            <a:r>
+              <a:t>Guter Lösungsweg: Kunde suchen, Engagement öffnen, Dokumentenablage/Sicherheiten prüfen – ohne beim Berater zurückzufragen.</a:t>
+            </a:r>
+          </a:p>
+          <a:p>
+            <a:r>
+              <a:t>Trainer-Hinweis: typischer Reflex ist die Rückfrage beim Berater statt der Recherche im System. Genau das sichtbar machen.</a:t>
+            </a:r>
+          </a:p>
+        </p:txBody>
+      </p:sp>
+      <p:sp>
+        <p:nvSpPr>
+          <p:cNvPr id="4" name="Slide Number Placeholder 3"/>
+          <p:cNvSpPr>
+            <a:spLocks noGrp="1"/>
+          </p:cNvSpPr>
+          <p:nvPr>
+            <p:ph type="sldNum" idx="5" sz="quarter"/>
+          </p:nvPr>
+        </p:nvSpPr>
+        <p:spPr/>
+      </p:sp>
+    </p:spTree>
+  </p:cSld>
+  <p:clrMapOvr>
+    <a:masterClrMapping/>
+  </p:clrMapOvr>
+</p:notes>
+</file>
+
+<file path=ppt/notesSlides/notesSlide8.xml><?xml version="1.0" encoding="utf-8"?>
+<p:notes xmlns:a="http://schemas.openxmlformats.org/drawingml/2006/main" xmlns:p="http://schemas.openxmlformats.org/presentationml/2006/main" xmlns:r="http://schemas.openxmlformats.org/officeDocument/2006/relationships">
+  <p:cSld>
+    <p:spTree>
+      <p:nvGrpSpPr>
+        <p:cNvPr id="1" name=""/>
+        <p:cNvGrpSpPr/>
+        <p:nvPr/>
+      </p:nvGrpSpPr>
+      <p:grpSpPr>
+        <a:xfrm>
+          <a:off x="0" y="0"/>
+          <a:ext cx="0" cy="0"/>
+          <a:chOff x="0" y="0"/>
+          <a:chExt cx="0" cy="0"/>
+        </a:xfrm>
+      </p:grpSpPr>
+      <p:sp>
+        <p:nvSpPr>
+          <p:cNvPr id="2" name="Slide Image Placeholder 1"/>
+          <p:cNvSpPr>
+            <a:spLocks noGrp="1"/>
+          </p:cNvSpPr>
+          <p:nvPr>
+            <p:ph type="sldImg" idx="2"/>
+          </p:nvPr>
+        </p:nvSpPr>
+        <p:spPr/>
+      </p:sp>
+      <p:sp>
+        <p:nvSpPr>
+          <p:cNvPr id="3" name="Notes Placeholder 2"/>
+          <p:cNvSpPr>
+            <a:spLocks noGrp="1"/>
+          </p:cNvSpPr>
+          <p:nvPr>
+            <p:ph type="body" idx="3" sz="quarter"/>
+          </p:nvPr>
+        </p:nvSpPr>
+        <p:spPr/>
+        <p:txBody>
+          <a:bodyPr/>
+          <a:lstStyle/>
+          <a:p>
+            <a:r>
+              <a:t>Überleitung zum Transfer: die zwei eigenen Workarounds aus AB-3 in die Tabelle von Sec 5.1 eintragen – letzter Systemschritt im Seminar.</a:t>
+            </a:r>
+          </a:p>
+        </p:txBody>
+      </p:sp>
+      <p:sp>
+        <p:nvSpPr>
+          <p:cNvPr id="4" name="Slide Number Placeholder 3"/>
+          <p:cNvSpPr>
+            <a:spLocks noGrp="1"/>
+          </p:cNvSpPr>
+          <p:nvPr>
+            <p:ph type="sldNum" idx="5" sz="quarter"/>
+          </p:nvPr>
+        </p:nvSpPr>
+        <p:spPr/>
+      </p:sp>
+    </p:spTree>
+  </p:cSld>
+  <p:clrMapOvr>
+    <a:masterClrMapping/>
+  </p:clrMapOvr>
+</p:notes>
+</file>
+
+<file path=ppt/notesSlides/notesSlide9.xml><?xml version="1.0" encoding="utf-8"?>
+<p:notes xmlns:a="http://schemas.openxmlformats.org/drawingml/2006/main" xmlns:p="http://schemas.openxmlformats.org/presentationml/2006/main" xmlns:r="http://schemas.openxmlformats.org/officeDocument/2006/relationships">
+  <p:cSld>
+    <p:spTree>
+      <p:nvGrpSpPr>
+        <p:cNvPr id="1" name=""/>
+        <p:cNvGrpSpPr/>
+        <p:nvPr/>
+      </p:nvGrpSpPr>
+      <p:grpSpPr>
+        <a:xfrm>
+          <a:off x="0" y="0"/>
+          <a:ext cx="0" cy="0"/>
+          <a:chOff x="0" y="0"/>
+          <a:chExt cx="0" cy="0"/>
+        </a:xfrm>
+      </p:grpSpPr>
+      <p:sp>
+        <p:nvSpPr>
+          <p:cNvPr id="2" name="Slide Image Placeholder 1"/>
+          <p:cNvSpPr>
+            <a:spLocks noGrp="1"/>
+          </p:cNvSpPr>
+          <p:nvPr>
+            <p:ph type="sldImg" idx="2"/>
+          </p:nvPr>
+        </p:nvSpPr>
+        <p:spPr/>
+      </p:sp>
+      <p:sp>
+        <p:nvSpPr>
+          <p:cNvPr id="3" name="Notes Placeholder 2"/>
+          <p:cNvSpPr>
+            <a:spLocks noGrp="1"/>
+          </p:cNvSpPr>
+          <p:nvPr>
+            <p:ph type="body" idx="3" sz="quarter"/>
+          </p:nvPr>
+        </p:nvSpPr>
+        <p:spPr/>
+        <p:txBody>
+          <a:bodyPr/>
+          <a:lstStyle/>
+          <a:p>
+            <a:r>
+              <a:t>Fragen 1 und 3 je eine kurze Runde im Plenum.</a:t>
             </a:r>
           </a:p>
         </p:txBody>
@@ -4380,6 +4658,2810 @@
 </p:sld>
 </file>
 
+<file path=ppt/slides/slide10.xml><?xml version="1.0" encoding="utf-8"?>
+<p:sld xmlns:a="http://schemas.openxmlformats.org/drawingml/2006/main" xmlns:p="http://schemas.openxmlformats.org/presentationml/2006/main" xmlns:r="http://schemas.openxmlformats.org/officeDocument/2006/relationships">
+  <p:cSld>
+    <p:spTree>
+      <p:nvGrpSpPr>
+        <p:cNvPr id="1" name=""/>
+        <p:cNvGrpSpPr/>
+        <p:nvPr/>
+      </p:nvGrpSpPr>
+      <p:grpSpPr/>
+      <p:sp>
+        <p:nvSpPr>
+          <p:cNvPr id="2" name="Rectangle 1"/>
+          <p:cNvSpPr/>
+          <p:nvPr/>
+        </p:nvSpPr>
+        <p:spPr>
+          <a:xfrm>
+            <a:off x="0" y="0"/>
+            <a:ext cx="12188952" cy="6858000"/>
+          </a:xfrm>
+          <a:prstGeom prst="rect">
+            <a:avLst/>
+          </a:prstGeom>
+          <a:solidFill>
+            <a:srgbClr val="FFFFFF"/>
+          </a:solidFill>
+          <a:ln>
+            <a:noFill/>
+          </a:ln>
+        </p:spPr>
+        <p:style>
+          <a:lnRef idx="1">
+            <a:schemeClr val="accent1"/>
+          </a:lnRef>
+          <a:fillRef idx="3">
+            <a:schemeClr val="accent1"/>
+          </a:fillRef>
+          <a:effectRef idx="2">
+            <a:schemeClr val="accent1"/>
+          </a:effectRef>
+          <a:fontRef idx="minor">
+            <a:schemeClr val="lt1"/>
+          </a:fontRef>
+        </p:style>
+        <p:txBody>
+          <a:bodyPr rtlCol="0" anchor="ctr"/>
+          <a:lstStyle/>
+          <a:p>
+            <a:pPr algn="ctr"/>
+          </a:p>
+        </p:txBody>
+      </p:sp>
+      <p:sp>
+        <p:nvSpPr>
+          <p:cNvPr id="3" name="Rectangle 2"/>
+          <p:cNvSpPr/>
+          <p:nvPr/>
+        </p:nvSpPr>
+        <p:spPr>
+          <a:xfrm>
+            <a:off x="0" y="0"/>
+            <a:ext cx="12188952" cy="50292"/>
+          </a:xfrm>
+          <a:prstGeom prst="rect">
+            <a:avLst/>
+          </a:prstGeom>
+          <a:solidFill>
+            <a:srgbClr val="1F2C56"/>
+          </a:solidFill>
+          <a:ln>
+            <a:noFill/>
+          </a:ln>
+        </p:spPr>
+        <p:style>
+          <a:lnRef idx="1">
+            <a:schemeClr val="accent1"/>
+          </a:lnRef>
+          <a:fillRef idx="3">
+            <a:schemeClr val="accent1"/>
+          </a:fillRef>
+          <a:effectRef idx="2">
+            <a:schemeClr val="accent1"/>
+          </a:effectRef>
+          <a:fontRef idx="minor">
+            <a:schemeClr val="lt1"/>
+          </a:fontRef>
+        </p:style>
+        <p:txBody>
+          <a:bodyPr rtlCol="0" anchor="ctr"/>
+          <a:lstStyle/>
+          <a:p>
+            <a:pPr algn="ctr"/>
+          </a:p>
+        </p:txBody>
+      </p:sp>
+      <p:sp>
+        <p:nvSpPr>
+          <p:cNvPr id="4" name="TextBox 3"/>
+          <p:cNvSpPr txBox="1"/>
+          <p:nvPr/>
+        </p:nvSpPr>
+        <p:spPr>
+          <a:xfrm>
+            <a:off x="685800" y="109728"/>
+            <a:ext cx="10817352" cy="228600"/>
+          </a:xfrm>
+          <a:prstGeom prst="rect">
+            <a:avLst/>
+          </a:prstGeom>
+          <a:noFill/>
+        </p:spPr>
+        <p:txBody>
+          <a:bodyPr wrap="none">
+            <a:spAutoFit/>
+          </a:bodyPr>
+          <a:lstStyle/>
+          <a:p>
+            <a:pPr algn="l"/>
+            <a:r>
+              <a:rPr sz="750">
+                <a:solidFill>
+                  <a:srgbClr val="78808C"/>
+                </a:solidFill>
+                <a:latin typeface="Consolas"/>
+              </a:rPr>
+              <a:t>VA03  ·  SCHAUBILD</a:t>
+            </a:r>
+          </a:p>
+        </p:txBody>
+      </p:sp>
+      <p:sp>
+        <p:nvSpPr>
+          <p:cNvPr id="5" name="TextBox 4"/>
+          <p:cNvSpPr txBox="1"/>
+          <p:nvPr/>
+        </p:nvSpPr>
+        <p:spPr>
+          <a:xfrm>
+            <a:off x="685800" y="502920"/>
+            <a:ext cx="10817352" cy="594360"/>
+          </a:xfrm>
+          <a:prstGeom prst="rect">
+            <a:avLst/>
+          </a:prstGeom>
+          <a:noFill/>
+        </p:spPr>
+        <p:txBody>
+          <a:bodyPr wrap="square">
+            <a:spAutoFit/>
+          </a:bodyPr>
+          <a:lstStyle/>
+          <a:p>
+            <a:pPr algn="l"/>
+            <a:r>
+              <a:rPr sz="2000" b="1" i="0">
+                <a:solidFill>
+                  <a:srgbClr val="1F2C56"/>
+                </a:solidFill>
+                <a:latin typeface="Arial"/>
+              </a:rPr>
+              <a:t>Was ein Workaround wirklich kostet</a:t>
+            </a:r>
+          </a:p>
+        </p:txBody>
+      </p:sp>
+      <p:sp>
+        <p:nvSpPr>
+          <p:cNvPr id="6" name="Rectangle 5"/>
+          <p:cNvSpPr/>
+          <p:nvPr/>
+        </p:nvSpPr>
+        <p:spPr>
+          <a:xfrm>
+            <a:off x="685800" y="1143000"/>
+            <a:ext cx="10817352" cy="25400"/>
+          </a:xfrm>
+          <a:prstGeom prst="rect">
+            <a:avLst/>
+          </a:prstGeom>
+          <a:solidFill>
+            <a:srgbClr val="D9C089"/>
+          </a:solidFill>
+          <a:ln>
+            <a:noFill/>
+          </a:ln>
+        </p:spPr>
+        <p:style>
+          <a:lnRef idx="1">
+            <a:schemeClr val="accent1"/>
+          </a:lnRef>
+          <a:fillRef idx="3">
+            <a:schemeClr val="accent1"/>
+          </a:fillRef>
+          <a:effectRef idx="2">
+            <a:schemeClr val="accent1"/>
+          </a:effectRef>
+          <a:fontRef idx="minor">
+            <a:schemeClr val="lt1"/>
+          </a:fontRef>
+        </p:style>
+        <p:txBody>
+          <a:bodyPr rtlCol="0" anchor="ctr"/>
+          <a:lstStyle/>
+          <a:p>
+            <a:pPr algn="ctr"/>
+          </a:p>
+        </p:txBody>
+      </p:sp>
+      <p:pic>
+        <p:nvPicPr>
+          <p:cNvPr id="7" name="Picture 6" descr="image.png"/>
+          <p:cNvPicPr>
+            <a:picLocks noChangeAspect="1"/>
+          </p:cNvPicPr>
+          <p:nvPr/>
+        </p:nvPicPr>
+        <p:blipFill>
+          <a:blip r:embed="rId2"/>
+          <a:stretch>
+            <a:fillRect/>
+          </a:stretch>
+        </p:blipFill>
+        <p:spPr>
+          <a:xfrm>
+            <a:off x="2009463" y="1325880"/>
+            <a:ext cx="8170026" cy="4937760"/>
+          </a:xfrm>
+          <a:prstGeom prst="rect">
+            <a:avLst/>
+          </a:prstGeom>
+        </p:spPr>
+      </p:pic>
+      <p:sp>
+        <p:nvSpPr>
+          <p:cNvPr id="8" name="Rectangle 7"/>
+          <p:cNvSpPr/>
+          <p:nvPr/>
+        </p:nvSpPr>
+        <p:spPr>
+          <a:xfrm>
+            <a:off x="0" y="6510528"/>
+            <a:ext cx="12188952" cy="347472"/>
+          </a:xfrm>
+          <a:prstGeom prst="rect">
+            <a:avLst/>
+          </a:prstGeom>
+          <a:solidFill>
+            <a:srgbClr val="0A1937"/>
+          </a:solidFill>
+          <a:ln>
+            <a:noFill/>
+          </a:ln>
+        </p:spPr>
+        <p:style>
+          <a:lnRef idx="1">
+            <a:schemeClr val="accent1"/>
+          </a:lnRef>
+          <a:fillRef idx="3">
+            <a:schemeClr val="accent1"/>
+          </a:fillRef>
+          <a:effectRef idx="2">
+            <a:schemeClr val="accent1"/>
+          </a:effectRef>
+          <a:fontRef idx="minor">
+            <a:schemeClr val="lt1"/>
+          </a:fontRef>
+        </p:style>
+        <p:txBody>
+          <a:bodyPr rtlCol="0" anchor="ctr"/>
+          <a:lstStyle/>
+          <a:p>
+            <a:pPr algn="ctr"/>
+          </a:p>
+        </p:txBody>
+      </p:sp>
+      <p:sp>
+        <p:nvSpPr>
+          <p:cNvPr id="9" name="TextBox 8"/>
+          <p:cNvSpPr txBox="1"/>
+          <p:nvPr/>
+        </p:nvSpPr>
+        <p:spPr>
+          <a:xfrm>
+            <a:off x="685800" y="6583680"/>
+            <a:ext cx="6490411" cy="256032"/>
+          </a:xfrm>
+          <a:prstGeom prst="rect">
+            <a:avLst/>
+          </a:prstGeom>
+          <a:noFill/>
+        </p:spPr>
+        <p:txBody>
+          <a:bodyPr wrap="none">
+            <a:spAutoFit/>
+          </a:bodyPr>
+          <a:lstStyle/>
+          <a:p>
+            <a:pPr algn="l"/>
+            <a:r>
+              <a:rPr sz="700">
+                <a:solidFill>
+                  <a:srgbClr val="A0B4D2"/>
+                </a:solidFill>
+                <a:latin typeface="Consolas"/>
+              </a:rPr>
+              <a:t>FKB Campus  ·  VA03</a:t>
+            </a:r>
+          </a:p>
+        </p:txBody>
+      </p:sp>
+      <p:sp>
+        <p:nvSpPr>
+          <p:cNvPr id="10" name="TextBox 9"/>
+          <p:cNvSpPr txBox="1"/>
+          <p:nvPr/>
+        </p:nvSpPr>
+        <p:spPr>
+          <a:xfrm>
+            <a:off x="7176211" y="6583680"/>
+            <a:ext cx="4326940" cy="256032"/>
+          </a:xfrm>
+          <a:prstGeom prst="rect">
+            <a:avLst/>
+          </a:prstGeom>
+          <a:noFill/>
+        </p:spPr>
+        <p:txBody>
+          <a:bodyPr wrap="none">
+            <a:spAutoFit/>
+          </a:bodyPr>
+          <a:lstStyle/>
+          <a:p>
+            <a:pPr algn="r"/>
+            <a:r>
+              <a:rPr sz="700">
+                <a:solidFill>
+                  <a:srgbClr val="A0B4D2"/>
+                </a:solidFill>
+                <a:latin typeface="Consolas"/>
+              </a:rPr>
+              <a:t>Schaubild</a:t>
+            </a:r>
+          </a:p>
+        </p:txBody>
+      </p:sp>
+    </p:spTree>
+  </p:cSld>
+  <p:clrMapOvr>
+    <a:masterClrMapping/>
+  </p:clrMapOvr>
+</p:sld>
+</file>
+
+<file path=ppt/slides/slide11.xml><?xml version="1.0" encoding="utf-8"?>
+<p:sld xmlns:a="http://schemas.openxmlformats.org/drawingml/2006/main" xmlns:p="http://schemas.openxmlformats.org/presentationml/2006/main" xmlns:r="http://schemas.openxmlformats.org/officeDocument/2006/relationships">
+  <p:cSld>
+    <p:spTree>
+      <p:nvGrpSpPr>
+        <p:cNvPr id="1" name=""/>
+        <p:cNvGrpSpPr/>
+        <p:nvPr/>
+      </p:nvGrpSpPr>
+      <p:grpSpPr/>
+      <p:sp>
+        <p:nvSpPr>
+          <p:cNvPr id="2" name="Rectangle 1"/>
+          <p:cNvSpPr/>
+          <p:nvPr/>
+        </p:nvSpPr>
+        <p:spPr>
+          <a:xfrm>
+            <a:off x="0" y="0"/>
+            <a:ext cx="12188952" cy="6858000"/>
+          </a:xfrm>
+          <a:prstGeom prst="rect">
+            <a:avLst/>
+          </a:prstGeom>
+          <a:solidFill>
+            <a:srgbClr val="1F2C56"/>
+          </a:solidFill>
+          <a:ln>
+            <a:noFill/>
+          </a:ln>
+        </p:spPr>
+        <p:style>
+          <a:lnRef idx="1">
+            <a:schemeClr val="accent1"/>
+          </a:lnRef>
+          <a:fillRef idx="3">
+            <a:schemeClr val="accent1"/>
+          </a:fillRef>
+          <a:effectRef idx="2">
+            <a:schemeClr val="accent1"/>
+          </a:effectRef>
+          <a:fontRef idx="minor">
+            <a:schemeClr val="lt1"/>
+          </a:fontRef>
+        </p:style>
+        <p:txBody>
+          <a:bodyPr rtlCol="0" anchor="ctr"/>
+          <a:lstStyle/>
+          <a:p>
+            <a:pPr algn="ctr"/>
+          </a:p>
+        </p:txBody>
+      </p:sp>
+      <p:sp>
+        <p:nvSpPr>
+          <p:cNvPr id="3" name="TextBox 2"/>
+          <p:cNvSpPr txBox="1"/>
+          <p:nvPr/>
+        </p:nvSpPr>
+        <p:spPr>
+          <a:xfrm>
+            <a:off x="685800" y="2377440"/>
+            <a:ext cx="10817352" cy="365760"/>
+          </a:xfrm>
+          <a:prstGeom prst="rect">
+            <a:avLst/>
+          </a:prstGeom>
+          <a:noFill/>
+        </p:spPr>
+        <p:txBody>
+          <a:bodyPr wrap="none">
+            <a:spAutoFit/>
+          </a:bodyPr>
+          <a:lstStyle/>
+          <a:p>
+            <a:pPr algn="l"/>
+            <a:r>
+              <a:rPr sz="1200">
+                <a:solidFill>
+                  <a:srgbClr val="D9C089"/>
+                </a:solidFill>
+                <a:latin typeface="Consolas"/>
+              </a:rPr>
+              <a:t>00:30–01:20</a:t>
+            </a:r>
+          </a:p>
+        </p:txBody>
+      </p:sp>
+      <p:sp>
+        <p:nvSpPr>
+          <p:cNvPr id="4" name="Rectangle 3"/>
+          <p:cNvSpPr/>
+          <p:nvPr/>
+        </p:nvSpPr>
+        <p:spPr>
+          <a:xfrm>
+            <a:off x="685800" y="2788920"/>
+            <a:ext cx="548640" cy="38100"/>
+          </a:xfrm>
+          <a:prstGeom prst="rect">
+            <a:avLst/>
+          </a:prstGeom>
+          <a:solidFill>
+            <a:srgbClr val="D9C089"/>
+          </a:solidFill>
+          <a:ln>
+            <a:noFill/>
+          </a:ln>
+        </p:spPr>
+        <p:style>
+          <a:lnRef idx="1">
+            <a:schemeClr val="accent1"/>
+          </a:lnRef>
+          <a:fillRef idx="3">
+            <a:schemeClr val="accent1"/>
+          </a:fillRef>
+          <a:effectRef idx="2">
+            <a:schemeClr val="accent1"/>
+          </a:effectRef>
+          <a:fontRef idx="minor">
+            <a:schemeClr val="lt1"/>
+          </a:fontRef>
+        </p:style>
+        <p:txBody>
+          <a:bodyPr rtlCol="0" anchor="ctr"/>
+          <a:lstStyle/>
+          <a:p>
+            <a:pPr algn="ctr"/>
+          </a:p>
+        </p:txBody>
+      </p:sp>
+      <p:sp>
+        <p:nvSpPr>
+          <p:cNvPr id="5" name="TextBox 4"/>
+          <p:cNvSpPr txBox="1"/>
+          <p:nvPr/>
+        </p:nvSpPr>
+        <p:spPr>
+          <a:xfrm>
+            <a:off x="685800" y="3017520"/>
+            <a:ext cx="10817352" cy="1463040"/>
+          </a:xfrm>
+          <a:prstGeom prst="rect">
+            <a:avLst/>
+          </a:prstGeom>
+          <a:noFill/>
+        </p:spPr>
+        <p:txBody>
+          <a:bodyPr wrap="square">
+            <a:spAutoFit/>
+          </a:bodyPr>
+          <a:lstStyle/>
+          <a:p>
+            <a:pPr algn="l"/>
+            <a:r>
+              <a:rPr sz="4000" b="1" i="0">
+                <a:solidFill>
+                  <a:srgbClr val="FFFFFF"/>
+                </a:solidFill>
+                <a:latin typeface="Arial"/>
+              </a:rPr>
+              <a:t>Fallübergabe &amp; Fallarbeit</a:t>
+            </a:r>
+          </a:p>
+        </p:txBody>
+      </p:sp>
+      <p:sp>
+        <p:nvSpPr>
+          <p:cNvPr id="6" name="TextBox 5"/>
+          <p:cNvSpPr txBox="1"/>
+          <p:nvPr/>
+        </p:nvSpPr>
+        <p:spPr>
+          <a:xfrm>
+            <a:off x="685800" y="4480560"/>
+            <a:ext cx="8653881" cy="1280160"/>
+          </a:xfrm>
+          <a:prstGeom prst="rect">
+            <a:avLst/>
+          </a:prstGeom>
+          <a:noFill/>
+        </p:spPr>
+        <p:txBody>
+          <a:bodyPr wrap="square">
+            <a:spAutoFit/>
+          </a:bodyPr>
+          <a:lstStyle/>
+          <a:p>
+            <a:pPr algn="l"/>
+            <a:r>
+              <a:rPr sz="1600" b="0" i="0">
+                <a:solidFill>
+                  <a:srgbClr val="C8D2E6"/>
+                </a:solidFill>
+                <a:latin typeface="Arial"/>
+              </a:rPr>
+              <a:t>Ein Innendienst-Vormittag bei der Metallbau Musterregion GmbH – drei Vorgänge, ein System.</a:t>
+            </a:r>
+          </a:p>
+        </p:txBody>
+      </p:sp>
+      <p:sp>
+        <p:nvSpPr>
+          <p:cNvPr id="7" name="TextBox 6"/>
+          <p:cNvSpPr txBox="1"/>
+          <p:nvPr/>
+        </p:nvSpPr>
+        <p:spPr>
+          <a:xfrm>
+            <a:off x="685800" y="6355080"/>
+            <a:ext cx="10817352" cy="274320"/>
+          </a:xfrm>
+          <a:prstGeom prst="rect">
+            <a:avLst/>
+          </a:prstGeom>
+          <a:noFill/>
+        </p:spPr>
+        <p:txBody>
+          <a:bodyPr wrap="none">
+            <a:spAutoFit/>
+          </a:bodyPr>
+          <a:lstStyle/>
+          <a:p>
+            <a:pPr algn="l"/>
+            <a:r>
+              <a:rPr sz="700">
+                <a:solidFill>
+                  <a:srgbClr val="8CA0C3"/>
+                </a:solidFill>
+                <a:latin typeface="Consolas"/>
+              </a:rPr>
+              <a:t>FKB Campus  ·  VA03</a:t>
+            </a:r>
+          </a:p>
+        </p:txBody>
+      </p:sp>
+    </p:spTree>
+  </p:cSld>
+  <p:clrMapOvr>
+    <a:masterClrMapping/>
+  </p:clrMapOvr>
+</p:sld>
+</file>
+
+<file path=ppt/slides/slide12.xml><?xml version="1.0" encoding="utf-8"?>
+<p:sld xmlns:a="http://schemas.openxmlformats.org/drawingml/2006/main" xmlns:p="http://schemas.openxmlformats.org/presentationml/2006/main" xmlns:r="http://schemas.openxmlformats.org/officeDocument/2006/relationships">
+  <p:cSld>
+    <p:spTree>
+      <p:nvGrpSpPr>
+        <p:cNvPr id="1" name=""/>
+        <p:cNvGrpSpPr/>
+        <p:nvPr/>
+      </p:nvGrpSpPr>
+      <p:grpSpPr/>
+      <p:sp>
+        <p:nvSpPr>
+          <p:cNvPr id="2" name="Rectangle 1"/>
+          <p:cNvSpPr/>
+          <p:nvPr/>
+        </p:nvSpPr>
+        <p:spPr>
+          <a:xfrm>
+            <a:off x="0" y="0"/>
+            <a:ext cx="12188952" cy="6858000"/>
+          </a:xfrm>
+          <a:prstGeom prst="rect">
+            <a:avLst/>
+          </a:prstGeom>
+          <a:solidFill>
+            <a:srgbClr val="EDEDF3"/>
+          </a:solidFill>
+          <a:ln>
+            <a:noFill/>
+          </a:ln>
+        </p:spPr>
+        <p:style>
+          <a:lnRef idx="1">
+            <a:schemeClr val="accent1"/>
+          </a:lnRef>
+          <a:fillRef idx="3">
+            <a:schemeClr val="accent1"/>
+          </a:fillRef>
+          <a:effectRef idx="2">
+            <a:schemeClr val="accent1"/>
+          </a:effectRef>
+          <a:fontRef idx="minor">
+            <a:schemeClr val="lt1"/>
+          </a:fontRef>
+        </p:style>
+        <p:txBody>
+          <a:bodyPr rtlCol="0" anchor="ctr"/>
+          <a:lstStyle/>
+          <a:p>
+            <a:pPr algn="ctr"/>
+          </a:p>
+        </p:txBody>
+      </p:sp>
+      <p:sp>
+        <p:nvSpPr>
+          <p:cNvPr id="3" name="Rectangle 2"/>
+          <p:cNvSpPr/>
+          <p:nvPr/>
+        </p:nvSpPr>
+        <p:spPr>
+          <a:xfrm>
+            <a:off x="0" y="0"/>
+            <a:ext cx="12188952" cy="50292"/>
+          </a:xfrm>
+          <a:prstGeom prst="rect">
+            <a:avLst/>
+          </a:prstGeom>
+          <a:solidFill>
+            <a:srgbClr val="1F2C56"/>
+          </a:solidFill>
+          <a:ln>
+            <a:noFill/>
+          </a:ln>
+        </p:spPr>
+        <p:style>
+          <a:lnRef idx="1">
+            <a:schemeClr val="accent1"/>
+          </a:lnRef>
+          <a:fillRef idx="3">
+            <a:schemeClr val="accent1"/>
+          </a:fillRef>
+          <a:effectRef idx="2">
+            <a:schemeClr val="accent1"/>
+          </a:effectRef>
+          <a:fontRef idx="minor">
+            <a:schemeClr val="lt1"/>
+          </a:fontRef>
+        </p:style>
+        <p:txBody>
+          <a:bodyPr rtlCol="0" anchor="ctr"/>
+          <a:lstStyle/>
+          <a:p>
+            <a:pPr algn="ctr"/>
+          </a:p>
+        </p:txBody>
+      </p:sp>
+      <p:sp>
+        <p:nvSpPr>
+          <p:cNvPr id="4" name="TextBox 3"/>
+          <p:cNvSpPr txBox="1"/>
+          <p:nvPr/>
+        </p:nvSpPr>
+        <p:spPr>
+          <a:xfrm>
+            <a:off x="685800" y="109728"/>
+            <a:ext cx="10817352" cy="228600"/>
+          </a:xfrm>
+          <a:prstGeom prst="rect">
+            <a:avLst/>
+          </a:prstGeom>
+          <a:noFill/>
+        </p:spPr>
+        <p:txBody>
+          <a:bodyPr wrap="none">
+            <a:spAutoFit/>
+          </a:bodyPr>
+          <a:lstStyle/>
+          <a:p>
+            <a:pPr algn="l"/>
+            <a:r>
+              <a:rPr sz="750">
+                <a:solidFill>
+                  <a:srgbClr val="78808C"/>
+                </a:solidFill>
+                <a:latin typeface="Consolas"/>
+              </a:rPr>
+              <a:t>VA03  ·  INHALT</a:t>
+            </a:r>
+          </a:p>
+        </p:txBody>
+      </p:sp>
+      <p:sp>
+        <p:nvSpPr>
+          <p:cNvPr id="5" name="Rectangle 4"/>
+          <p:cNvSpPr/>
+          <p:nvPr/>
+        </p:nvSpPr>
+        <p:spPr>
+          <a:xfrm>
+            <a:off x="0" y="1234440"/>
+            <a:ext cx="12188952" cy="12700"/>
+          </a:xfrm>
+          <a:prstGeom prst="rect">
+            <a:avLst/>
+          </a:prstGeom>
+          <a:solidFill>
+            <a:srgbClr val="D8DFE4"/>
+          </a:solidFill>
+          <a:ln>
+            <a:noFill/>
+          </a:ln>
+        </p:spPr>
+        <p:style>
+          <a:lnRef idx="1">
+            <a:schemeClr val="accent1"/>
+          </a:lnRef>
+          <a:fillRef idx="3">
+            <a:schemeClr val="accent1"/>
+          </a:fillRef>
+          <a:effectRef idx="2">
+            <a:schemeClr val="accent1"/>
+          </a:effectRef>
+          <a:fontRef idx="minor">
+            <a:schemeClr val="lt1"/>
+          </a:fontRef>
+        </p:style>
+        <p:txBody>
+          <a:bodyPr rtlCol="0" anchor="ctr"/>
+          <a:lstStyle/>
+          <a:p>
+            <a:pPr algn="ctr"/>
+          </a:p>
+        </p:txBody>
+      </p:sp>
+      <p:sp>
+        <p:nvSpPr>
+          <p:cNvPr id="6" name="Rectangle 5"/>
+          <p:cNvSpPr/>
+          <p:nvPr/>
+        </p:nvSpPr>
+        <p:spPr>
+          <a:xfrm>
+            <a:off x="685800" y="502920"/>
+            <a:ext cx="36576" cy="658368"/>
+          </a:xfrm>
+          <a:prstGeom prst="rect">
+            <a:avLst/>
+          </a:prstGeom>
+          <a:solidFill>
+            <a:srgbClr val="D9C089"/>
+          </a:solidFill>
+          <a:ln>
+            <a:noFill/>
+          </a:ln>
+        </p:spPr>
+        <p:style>
+          <a:lnRef idx="1">
+            <a:schemeClr val="accent1"/>
+          </a:lnRef>
+          <a:fillRef idx="3">
+            <a:schemeClr val="accent1"/>
+          </a:fillRef>
+          <a:effectRef idx="2">
+            <a:schemeClr val="accent1"/>
+          </a:effectRef>
+          <a:fontRef idx="minor">
+            <a:schemeClr val="lt1"/>
+          </a:fontRef>
+        </p:style>
+        <p:txBody>
+          <a:bodyPr rtlCol="0" anchor="ctr"/>
+          <a:lstStyle/>
+          <a:p>
+            <a:pPr algn="ctr"/>
+          </a:p>
+        </p:txBody>
+      </p:sp>
+      <p:sp>
+        <p:nvSpPr>
+          <p:cNvPr id="7" name="TextBox 6"/>
+          <p:cNvSpPr txBox="1"/>
+          <p:nvPr/>
+        </p:nvSpPr>
+        <p:spPr>
+          <a:xfrm>
+            <a:off x="813816" y="502920"/>
+            <a:ext cx="10634472" cy="685800"/>
+          </a:xfrm>
+          <a:prstGeom prst="rect">
+            <a:avLst/>
+          </a:prstGeom>
+          <a:noFill/>
+        </p:spPr>
+        <p:txBody>
+          <a:bodyPr wrap="square">
+            <a:spAutoFit/>
+          </a:bodyPr>
+          <a:lstStyle/>
+          <a:p>
+            <a:pPr algn="l"/>
+            <a:r>
+              <a:rPr sz="2400" b="1" i="0">
+                <a:solidFill>
+                  <a:srgbClr val="1F2C56"/>
+                </a:solidFill>
+                <a:latin typeface="Arial"/>
+              </a:rPr>
+              <a:t>Praxisfall: Ein Vormittag im Innendienst</a:t>
+            </a:r>
+          </a:p>
+        </p:txBody>
+      </p:sp>
+      <p:sp>
+        <p:nvSpPr>
+          <p:cNvPr id="8" name="TextBox 7"/>
+          <p:cNvSpPr txBox="1"/>
+          <p:nvPr/>
+        </p:nvSpPr>
+        <p:spPr>
+          <a:xfrm>
+            <a:off x="685800" y="1417320"/>
+            <a:ext cx="10817352" cy="4892040"/>
+          </a:xfrm>
+          <a:prstGeom prst="rect">
+            <a:avLst/>
+          </a:prstGeom>
+          <a:noFill/>
+        </p:spPr>
+        <p:txBody>
+          <a:bodyPr wrap="square" anchor="ctr">
+            <a:spAutoFit/>
+          </a:bodyPr>
+          <a:lstStyle/>
+          <a:p>
+            <a:pPr>
+              <a:spcBef>
+                <a:spcPts val="1000"/>
+              </a:spcBef>
+              <a:spcAft>
+                <a:spcPts val="200"/>
+              </a:spcAft>
+            </a:pPr>
+            <a:r>
+              <a:rPr sz="800" b="1">
+                <a:solidFill>
+                  <a:srgbClr val="78808C"/>
+                </a:solidFill>
+                <a:latin typeface="Consolas"/>
+              </a:rPr>
+              <a:t>DER FALL</a:t>
+            </a:r>
+          </a:p>
+          <a:p>
+            <a:pPr marL="190500" indent="-190500">
+              <a:spcBef>
+                <a:spcPts val="400"/>
+              </a:spcBef>
+              <a:spcAft>
+                <a:spcPts val="200"/>
+              </a:spcAft>
+            </a:pPr>
+            <a:r>
+              <a:rPr sz="1300">
+                <a:solidFill>
+                  <a:srgbClr val="3D5466"/>
+                </a:solidFill>
+                <a:latin typeface="Arial"/>
+              </a:rPr>
+              <a:t>▸  Sie betreuen das Engagement der Metallbau Musterregion GmbH (Hausbank VR-Bank Musterregion eG).</a:t>
+            </a:r>
+          </a:p>
+          <a:p>
+            <a:pPr marL="190500" indent="-190500">
+              <a:spcBef>
+                <a:spcPts val="400"/>
+              </a:spcBef>
+              <a:spcAft>
+                <a:spcPts val="200"/>
+              </a:spcAft>
+            </a:pPr>
+            <a:r>
+              <a:rPr sz="1300">
+                <a:solidFill>
+                  <a:srgbClr val="3D5466"/>
+                </a:solidFill>
+                <a:latin typeface="Arial"/>
+              </a:rPr>
+              <a:t>▸  An einem Vormittag laufen drei Vorgänge auf: eine Beraternachfrage, eine Adressänderung und eine fehlende BWA.</a:t>
+            </a:r>
+          </a:p>
+          <a:p>
+            <a:pPr>
+              <a:spcBef>
+                <a:spcPts val="1000"/>
+              </a:spcBef>
+              <a:spcAft>
+                <a:spcPts val="200"/>
+              </a:spcAft>
+            </a:pPr>
+            <a:r>
+              <a:rPr sz="800" b="1">
+                <a:solidFill>
+                  <a:srgbClr val="78808C"/>
+                </a:solidFill>
+                <a:latin typeface="Consolas"/>
+              </a:rPr>
+              <a:t>IHRE AUFGABE</a:t>
+            </a:r>
+          </a:p>
+          <a:p>
+            <a:pPr marL="190500" indent="-190500">
+              <a:spcBef>
+                <a:spcPts val="400"/>
+              </a:spcBef>
+              <a:spcAft>
+                <a:spcPts val="200"/>
+              </a:spcAft>
+            </a:pPr>
+            <a:r>
+              <a:rPr sz="1300">
+                <a:solidFill>
+                  <a:srgbClr val="3D5466"/>
+                </a:solidFill>
+                <a:latin typeface="Arial"/>
+              </a:rPr>
+              <a:t>▸  Bearbeiten Sie alle drei Vorgänge vollständig in agree – ohne Notizzettel, ohne Rückfrage beim Berater.</a:t>
+            </a:r>
+          </a:p>
+        </p:txBody>
+      </p:sp>
+      <p:sp>
+        <p:nvSpPr>
+          <p:cNvPr id="9" name="Rectangle 8"/>
+          <p:cNvSpPr/>
+          <p:nvPr/>
+        </p:nvSpPr>
+        <p:spPr>
+          <a:xfrm>
+            <a:off x="0" y="6510528"/>
+            <a:ext cx="12188952" cy="347472"/>
+          </a:xfrm>
+          <a:prstGeom prst="rect">
+            <a:avLst/>
+          </a:prstGeom>
+          <a:solidFill>
+            <a:srgbClr val="0A1937"/>
+          </a:solidFill>
+          <a:ln>
+            <a:noFill/>
+          </a:ln>
+        </p:spPr>
+        <p:style>
+          <a:lnRef idx="1">
+            <a:schemeClr val="accent1"/>
+          </a:lnRef>
+          <a:fillRef idx="3">
+            <a:schemeClr val="accent1"/>
+          </a:fillRef>
+          <a:effectRef idx="2">
+            <a:schemeClr val="accent1"/>
+          </a:effectRef>
+          <a:fontRef idx="minor">
+            <a:schemeClr val="lt1"/>
+          </a:fontRef>
+        </p:style>
+        <p:txBody>
+          <a:bodyPr rtlCol="0" anchor="ctr"/>
+          <a:lstStyle/>
+          <a:p>
+            <a:pPr algn="ctr"/>
+          </a:p>
+        </p:txBody>
+      </p:sp>
+      <p:sp>
+        <p:nvSpPr>
+          <p:cNvPr id="10" name="TextBox 9"/>
+          <p:cNvSpPr txBox="1"/>
+          <p:nvPr/>
+        </p:nvSpPr>
+        <p:spPr>
+          <a:xfrm>
+            <a:off x="685800" y="6583680"/>
+            <a:ext cx="6490411" cy="256032"/>
+          </a:xfrm>
+          <a:prstGeom prst="rect">
+            <a:avLst/>
+          </a:prstGeom>
+          <a:noFill/>
+        </p:spPr>
+        <p:txBody>
+          <a:bodyPr wrap="none">
+            <a:spAutoFit/>
+          </a:bodyPr>
+          <a:lstStyle/>
+          <a:p>
+            <a:pPr algn="l"/>
+            <a:r>
+              <a:rPr sz="700">
+                <a:solidFill>
+                  <a:srgbClr val="A0B4D2"/>
+                </a:solidFill>
+                <a:latin typeface="Consolas"/>
+              </a:rPr>
+              <a:t>FKB Campus  ·  VA03</a:t>
+            </a:r>
+          </a:p>
+        </p:txBody>
+      </p:sp>
+    </p:spTree>
+  </p:cSld>
+  <p:clrMapOvr>
+    <a:masterClrMapping/>
+  </p:clrMapOvr>
+</p:sld>
+</file>
+
+<file path=ppt/slides/slide13.xml><?xml version="1.0" encoding="utf-8"?>
+<p:sld xmlns:a="http://schemas.openxmlformats.org/drawingml/2006/main" xmlns:p="http://schemas.openxmlformats.org/presentationml/2006/main" xmlns:r="http://schemas.openxmlformats.org/officeDocument/2006/relationships">
+  <p:cSld>
+    <p:spTree>
+      <p:nvGrpSpPr>
+        <p:cNvPr id="1" name=""/>
+        <p:cNvGrpSpPr/>
+        <p:nvPr/>
+      </p:nvGrpSpPr>
+      <p:grpSpPr/>
+      <p:sp>
+        <p:nvSpPr>
+          <p:cNvPr id="2" name="Rectangle 1"/>
+          <p:cNvSpPr/>
+          <p:nvPr/>
+        </p:nvSpPr>
+        <p:spPr>
+          <a:xfrm>
+            <a:off x="0" y="0"/>
+            <a:ext cx="12188952" cy="6858000"/>
+          </a:xfrm>
+          <a:prstGeom prst="rect">
+            <a:avLst/>
+          </a:prstGeom>
+          <a:solidFill>
+            <a:srgbClr val="EDEDF3"/>
+          </a:solidFill>
+          <a:ln>
+            <a:noFill/>
+          </a:ln>
+        </p:spPr>
+        <p:style>
+          <a:lnRef idx="1">
+            <a:schemeClr val="accent1"/>
+          </a:lnRef>
+          <a:fillRef idx="3">
+            <a:schemeClr val="accent1"/>
+          </a:fillRef>
+          <a:effectRef idx="2">
+            <a:schemeClr val="accent1"/>
+          </a:effectRef>
+          <a:fontRef idx="minor">
+            <a:schemeClr val="lt1"/>
+          </a:fontRef>
+        </p:style>
+        <p:txBody>
+          <a:bodyPr rtlCol="0" anchor="ctr"/>
+          <a:lstStyle/>
+          <a:p>
+            <a:pPr algn="ctr"/>
+          </a:p>
+        </p:txBody>
+      </p:sp>
+      <p:sp>
+        <p:nvSpPr>
+          <p:cNvPr id="3" name="Rectangle 2"/>
+          <p:cNvSpPr/>
+          <p:nvPr/>
+        </p:nvSpPr>
+        <p:spPr>
+          <a:xfrm>
+            <a:off x="0" y="0"/>
+            <a:ext cx="12188952" cy="50292"/>
+          </a:xfrm>
+          <a:prstGeom prst="rect">
+            <a:avLst/>
+          </a:prstGeom>
+          <a:solidFill>
+            <a:srgbClr val="1F2C56"/>
+          </a:solidFill>
+          <a:ln>
+            <a:noFill/>
+          </a:ln>
+        </p:spPr>
+        <p:style>
+          <a:lnRef idx="1">
+            <a:schemeClr val="accent1"/>
+          </a:lnRef>
+          <a:fillRef idx="3">
+            <a:schemeClr val="accent1"/>
+          </a:fillRef>
+          <a:effectRef idx="2">
+            <a:schemeClr val="accent1"/>
+          </a:effectRef>
+          <a:fontRef idx="minor">
+            <a:schemeClr val="lt1"/>
+          </a:fontRef>
+        </p:style>
+        <p:txBody>
+          <a:bodyPr rtlCol="0" anchor="ctr"/>
+          <a:lstStyle/>
+          <a:p>
+            <a:pPr algn="ctr"/>
+          </a:p>
+        </p:txBody>
+      </p:sp>
+      <p:sp>
+        <p:nvSpPr>
+          <p:cNvPr id="4" name="TextBox 3"/>
+          <p:cNvSpPr txBox="1"/>
+          <p:nvPr/>
+        </p:nvSpPr>
+        <p:spPr>
+          <a:xfrm>
+            <a:off x="685800" y="109728"/>
+            <a:ext cx="10817352" cy="228600"/>
+          </a:xfrm>
+          <a:prstGeom prst="rect">
+            <a:avLst/>
+          </a:prstGeom>
+          <a:noFill/>
+        </p:spPr>
+        <p:txBody>
+          <a:bodyPr wrap="none">
+            <a:spAutoFit/>
+          </a:bodyPr>
+          <a:lstStyle/>
+          <a:p>
+            <a:pPr algn="l"/>
+            <a:r>
+              <a:rPr sz="750">
+                <a:solidFill>
+                  <a:srgbClr val="78808C"/>
+                </a:solidFill>
+                <a:latin typeface="Consolas"/>
+              </a:rPr>
+              <a:t>VA03  ·  INHALT</a:t>
+            </a:r>
+          </a:p>
+        </p:txBody>
+      </p:sp>
+      <p:sp>
+        <p:nvSpPr>
+          <p:cNvPr id="5" name="Rectangle 4"/>
+          <p:cNvSpPr/>
+          <p:nvPr/>
+        </p:nvSpPr>
+        <p:spPr>
+          <a:xfrm>
+            <a:off x="0" y="1234440"/>
+            <a:ext cx="12188952" cy="12700"/>
+          </a:xfrm>
+          <a:prstGeom prst="rect">
+            <a:avLst/>
+          </a:prstGeom>
+          <a:solidFill>
+            <a:srgbClr val="D8DFE4"/>
+          </a:solidFill>
+          <a:ln>
+            <a:noFill/>
+          </a:ln>
+        </p:spPr>
+        <p:style>
+          <a:lnRef idx="1">
+            <a:schemeClr val="accent1"/>
+          </a:lnRef>
+          <a:fillRef idx="3">
+            <a:schemeClr val="accent1"/>
+          </a:fillRef>
+          <a:effectRef idx="2">
+            <a:schemeClr val="accent1"/>
+          </a:effectRef>
+          <a:fontRef idx="minor">
+            <a:schemeClr val="lt1"/>
+          </a:fontRef>
+        </p:style>
+        <p:txBody>
+          <a:bodyPr rtlCol="0" anchor="ctr"/>
+          <a:lstStyle/>
+          <a:p>
+            <a:pPr algn="ctr"/>
+          </a:p>
+        </p:txBody>
+      </p:sp>
+      <p:sp>
+        <p:nvSpPr>
+          <p:cNvPr id="6" name="Rectangle 5"/>
+          <p:cNvSpPr/>
+          <p:nvPr/>
+        </p:nvSpPr>
+        <p:spPr>
+          <a:xfrm>
+            <a:off x="685800" y="502920"/>
+            <a:ext cx="36576" cy="658368"/>
+          </a:xfrm>
+          <a:prstGeom prst="rect">
+            <a:avLst/>
+          </a:prstGeom>
+          <a:solidFill>
+            <a:srgbClr val="D9C089"/>
+          </a:solidFill>
+          <a:ln>
+            <a:noFill/>
+          </a:ln>
+        </p:spPr>
+        <p:style>
+          <a:lnRef idx="1">
+            <a:schemeClr val="accent1"/>
+          </a:lnRef>
+          <a:fillRef idx="3">
+            <a:schemeClr val="accent1"/>
+          </a:fillRef>
+          <a:effectRef idx="2">
+            <a:schemeClr val="accent1"/>
+          </a:effectRef>
+          <a:fontRef idx="minor">
+            <a:schemeClr val="lt1"/>
+          </a:fontRef>
+        </p:style>
+        <p:txBody>
+          <a:bodyPr rtlCol="0" anchor="ctr"/>
+          <a:lstStyle/>
+          <a:p>
+            <a:pPr algn="ctr"/>
+          </a:p>
+        </p:txBody>
+      </p:sp>
+      <p:sp>
+        <p:nvSpPr>
+          <p:cNvPr id="7" name="TextBox 6"/>
+          <p:cNvSpPr txBox="1"/>
+          <p:nvPr/>
+        </p:nvSpPr>
+        <p:spPr>
+          <a:xfrm>
+            <a:off x="813816" y="502920"/>
+            <a:ext cx="10634472" cy="685800"/>
+          </a:xfrm>
+          <a:prstGeom prst="rect">
+            <a:avLst/>
+          </a:prstGeom>
+          <a:noFill/>
+        </p:spPr>
+        <p:txBody>
+          <a:bodyPr wrap="square">
+            <a:spAutoFit/>
+          </a:bodyPr>
+          <a:lstStyle/>
+          <a:p>
+            <a:pPr algn="l"/>
+            <a:r>
+              <a:rPr sz="2400" b="1" i="0">
+                <a:solidFill>
+                  <a:srgbClr val="1F2C56"/>
+                </a:solidFill>
+                <a:latin typeface="Arial"/>
+              </a:rPr>
+              <a:t>Handlungsempfehlung: statt Workaround ins System</a:t>
+            </a:r>
+          </a:p>
+        </p:txBody>
+      </p:sp>
+      <p:sp>
+        <p:nvSpPr>
+          <p:cNvPr id="8" name="TextBox 7"/>
+          <p:cNvSpPr txBox="1"/>
+          <p:nvPr/>
+        </p:nvSpPr>
+        <p:spPr>
+          <a:xfrm>
+            <a:off x="685800" y="1417320"/>
+            <a:ext cx="10817352" cy="4892040"/>
+          </a:xfrm>
+          <a:prstGeom prst="rect">
+            <a:avLst/>
+          </a:prstGeom>
+          <a:noFill/>
+        </p:spPr>
+        <p:txBody>
+          <a:bodyPr wrap="square" anchor="ctr">
+            <a:spAutoFit/>
+          </a:bodyPr>
+          <a:lstStyle/>
+          <a:p>
+            <a:pPr marL="177800" indent="-177800">
+              <a:spcBef>
+                <a:spcPts val="600"/>
+              </a:spcBef>
+              <a:spcAft>
+                <a:spcPts val="200"/>
+              </a:spcAft>
+            </a:pPr>
+            <a:r>
+              <a:rPr sz="1200" i="1">
+                <a:solidFill>
+                  <a:srgbClr val="3D5466"/>
+                </a:solidFill>
+                <a:latin typeface="Arial"/>
+              </a:rPr>
+              <a:t>→  Wenn eine Information mündlich oder per Notiz hereinkommt — dann sie direkt im System erfassen und dem Vorgang zuordnen (eine Wahrheit).</a:t>
+            </a:r>
+          </a:p>
+          <a:p>
+            <a:pPr marL="177800" indent="-177800">
+              <a:spcBef>
+                <a:spcPts val="600"/>
+              </a:spcBef>
+              <a:spcAft>
+                <a:spcPts val="200"/>
+              </a:spcAft>
+            </a:pPr>
+            <a:r>
+              <a:rPr sz="1200" i="1">
+                <a:solidFill>
+                  <a:srgbClr val="3D5466"/>
+                </a:solidFill>
+                <a:latin typeface="Arial"/>
+              </a:rPr>
+              <a:t>→  Wenn eine Aufgabe später erledigt werden muss — dann eine Wiedervorlage mit Frist anlegen, statt sie im Kopf zu behalten.</a:t>
+            </a:r>
+          </a:p>
+          <a:p>
+            <a:pPr marL="177800" indent="-177800">
+              <a:spcBef>
+                <a:spcPts val="600"/>
+              </a:spcBef>
+              <a:spcAft>
+                <a:spcPts val="200"/>
+              </a:spcAft>
+            </a:pPr>
+            <a:r>
+              <a:rPr sz="1200" i="1">
+                <a:solidFill>
+                  <a:srgbClr val="3D5466"/>
+                </a:solidFill>
+                <a:latin typeface="Arial"/>
+              </a:rPr>
+              <a:t>→  Wenn Kundendaten in einer Liste außerhalb des Systems stehen — dann sie ins System überführen und die Liste löschen (DSGVO).</a:t>
+            </a:r>
+          </a:p>
+        </p:txBody>
+      </p:sp>
+      <p:sp>
+        <p:nvSpPr>
+          <p:cNvPr id="9" name="Rectangle 8"/>
+          <p:cNvSpPr/>
+          <p:nvPr/>
+        </p:nvSpPr>
+        <p:spPr>
+          <a:xfrm>
+            <a:off x="0" y="6510528"/>
+            <a:ext cx="12188952" cy="347472"/>
+          </a:xfrm>
+          <a:prstGeom prst="rect">
+            <a:avLst/>
+          </a:prstGeom>
+          <a:solidFill>
+            <a:srgbClr val="0A1937"/>
+          </a:solidFill>
+          <a:ln>
+            <a:noFill/>
+          </a:ln>
+        </p:spPr>
+        <p:style>
+          <a:lnRef idx="1">
+            <a:schemeClr val="accent1"/>
+          </a:lnRef>
+          <a:fillRef idx="3">
+            <a:schemeClr val="accent1"/>
+          </a:fillRef>
+          <a:effectRef idx="2">
+            <a:schemeClr val="accent1"/>
+          </a:effectRef>
+          <a:fontRef idx="minor">
+            <a:schemeClr val="lt1"/>
+          </a:fontRef>
+        </p:style>
+        <p:txBody>
+          <a:bodyPr rtlCol="0" anchor="ctr"/>
+          <a:lstStyle/>
+          <a:p>
+            <a:pPr algn="ctr"/>
+          </a:p>
+        </p:txBody>
+      </p:sp>
+      <p:sp>
+        <p:nvSpPr>
+          <p:cNvPr id="10" name="TextBox 9"/>
+          <p:cNvSpPr txBox="1"/>
+          <p:nvPr/>
+        </p:nvSpPr>
+        <p:spPr>
+          <a:xfrm>
+            <a:off x="685800" y="6583680"/>
+            <a:ext cx="6490411" cy="256032"/>
+          </a:xfrm>
+          <a:prstGeom prst="rect">
+            <a:avLst/>
+          </a:prstGeom>
+          <a:noFill/>
+        </p:spPr>
+        <p:txBody>
+          <a:bodyPr wrap="none">
+            <a:spAutoFit/>
+          </a:bodyPr>
+          <a:lstStyle/>
+          <a:p>
+            <a:pPr algn="l"/>
+            <a:r>
+              <a:rPr sz="700">
+                <a:solidFill>
+                  <a:srgbClr val="A0B4D2"/>
+                </a:solidFill>
+                <a:latin typeface="Consolas"/>
+              </a:rPr>
+              <a:t>FKB Campus  ·  VA03</a:t>
+            </a:r>
+          </a:p>
+        </p:txBody>
+      </p:sp>
+    </p:spTree>
+  </p:cSld>
+  <p:clrMapOvr>
+    <a:masterClrMapping/>
+  </p:clrMapOvr>
+</p:sld>
+</file>
+
+<file path=ppt/slides/slide14.xml><?xml version="1.0" encoding="utf-8"?>
+<p:sld xmlns:a="http://schemas.openxmlformats.org/drawingml/2006/main" xmlns:p="http://schemas.openxmlformats.org/presentationml/2006/main" xmlns:r="http://schemas.openxmlformats.org/officeDocument/2006/relationships">
+  <p:cSld>
+    <p:spTree>
+      <p:nvGrpSpPr>
+        <p:cNvPr id="1" name=""/>
+        <p:cNvGrpSpPr/>
+        <p:nvPr/>
+      </p:nvGrpSpPr>
+      <p:grpSpPr/>
+      <p:sp>
+        <p:nvSpPr>
+          <p:cNvPr id="2" name="Rectangle 1"/>
+          <p:cNvSpPr/>
+          <p:nvPr/>
+        </p:nvSpPr>
+        <p:spPr>
+          <a:xfrm>
+            <a:off x="0" y="0"/>
+            <a:ext cx="12188952" cy="6858000"/>
+          </a:xfrm>
+          <a:prstGeom prst="rect">
+            <a:avLst/>
+          </a:prstGeom>
+          <a:solidFill>
+            <a:srgbClr val="EDEDF3"/>
+          </a:solidFill>
+          <a:ln>
+            <a:noFill/>
+          </a:ln>
+        </p:spPr>
+        <p:style>
+          <a:lnRef idx="1">
+            <a:schemeClr val="accent1"/>
+          </a:lnRef>
+          <a:fillRef idx="3">
+            <a:schemeClr val="accent1"/>
+          </a:fillRef>
+          <a:effectRef idx="2">
+            <a:schemeClr val="accent1"/>
+          </a:effectRef>
+          <a:fontRef idx="minor">
+            <a:schemeClr val="lt1"/>
+          </a:fontRef>
+        </p:style>
+        <p:txBody>
+          <a:bodyPr rtlCol="0" anchor="ctr"/>
+          <a:lstStyle/>
+          <a:p>
+            <a:pPr algn="ctr"/>
+          </a:p>
+        </p:txBody>
+      </p:sp>
+      <p:sp>
+        <p:nvSpPr>
+          <p:cNvPr id="3" name="Rectangle 2"/>
+          <p:cNvSpPr/>
+          <p:nvPr/>
+        </p:nvSpPr>
+        <p:spPr>
+          <a:xfrm>
+            <a:off x="0" y="0"/>
+            <a:ext cx="12188952" cy="50292"/>
+          </a:xfrm>
+          <a:prstGeom prst="rect">
+            <a:avLst/>
+          </a:prstGeom>
+          <a:solidFill>
+            <a:srgbClr val="1F2C56"/>
+          </a:solidFill>
+          <a:ln>
+            <a:noFill/>
+          </a:ln>
+        </p:spPr>
+        <p:style>
+          <a:lnRef idx="1">
+            <a:schemeClr val="accent1"/>
+          </a:lnRef>
+          <a:fillRef idx="3">
+            <a:schemeClr val="accent1"/>
+          </a:fillRef>
+          <a:effectRef idx="2">
+            <a:schemeClr val="accent1"/>
+          </a:effectRef>
+          <a:fontRef idx="minor">
+            <a:schemeClr val="lt1"/>
+          </a:fontRef>
+        </p:style>
+        <p:txBody>
+          <a:bodyPr rtlCol="0" anchor="ctr"/>
+          <a:lstStyle/>
+          <a:p>
+            <a:pPr algn="ctr"/>
+          </a:p>
+        </p:txBody>
+      </p:sp>
+      <p:sp>
+        <p:nvSpPr>
+          <p:cNvPr id="4" name="TextBox 3"/>
+          <p:cNvSpPr txBox="1"/>
+          <p:nvPr/>
+        </p:nvSpPr>
+        <p:spPr>
+          <a:xfrm>
+            <a:off x="685800" y="109728"/>
+            <a:ext cx="10817352" cy="228600"/>
+          </a:xfrm>
+          <a:prstGeom prst="rect">
+            <a:avLst/>
+          </a:prstGeom>
+          <a:noFill/>
+        </p:spPr>
+        <p:txBody>
+          <a:bodyPr wrap="none">
+            <a:spAutoFit/>
+          </a:bodyPr>
+          <a:lstStyle/>
+          <a:p>
+            <a:pPr algn="l"/>
+            <a:r>
+              <a:rPr sz="750">
+                <a:solidFill>
+                  <a:srgbClr val="78808C"/>
+                </a:solidFill>
+                <a:latin typeface="Consolas"/>
+              </a:rPr>
+              <a:t>VA03  ·  ARBEITSBLATT</a:t>
+            </a:r>
+          </a:p>
+        </p:txBody>
+      </p:sp>
+      <p:sp>
+        <p:nvSpPr>
+          <p:cNvPr id="5" name="Rectangle 4"/>
+          <p:cNvSpPr/>
+          <p:nvPr/>
+        </p:nvSpPr>
+        <p:spPr>
+          <a:xfrm>
+            <a:off x="0" y="1234440"/>
+            <a:ext cx="12188952" cy="12700"/>
+          </a:xfrm>
+          <a:prstGeom prst="rect">
+            <a:avLst/>
+          </a:prstGeom>
+          <a:solidFill>
+            <a:srgbClr val="D8DFE4"/>
+          </a:solidFill>
+          <a:ln>
+            <a:noFill/>
+          </a:ln>
+        </p:spPr>
+        <p:style>
+          <a:lnRef idx="1">
+            <a:schemeClr val="accent1"/>
+          </a:lnRef>
+          <a:fillRef idx="3">
+            <a:schemeClr val="accent1"/>
+          </a:fillRef>
+          <a:effectRef idx="2">
+            <a:schemeClr val="accent1"/>
+          </a:effectRef>
+          <a:fontRef idx="minor">
+            <a:schemeClr val="lt1"/>
+          </a:fontRef>
+        </p:style>
+        <p:txBody>
+          <a:bodyPr rtlCol="0" anchor="ctr"/>
+          <a:lstStyle/>
+          <a:p>
+            <a:pPr algn="ctr"/>
+          </a:p>
+        </p:txBody>
+      </p:sp>
+      <p:sp>
+        <p:nvSpPr>
+          <p:cNvPr id="6" name="Rectangle 5"/>
+          <p:cNvSpPr/>
+          <p:nvPr/>
+        </p:nvSpPr>
+        <p:spPr>
+          <a:xfrm>
+            <a:off x="685800" y="502920"/>
+            <a:ext cx="36576" cy="658368"/>
+          </a:xfrm>
+          <a:prstGeom prst="rect">
+            <a:avLst/>
+          </a:prstGeom>
+          <a:solidFill>
+            <a:srgbClr val="D9C089"/>
+          </a:solidFill>
+          <a:ln>
+            <a:noFill/>
+          </a:ln>
+        </p:spPr>
+        <p:style>
+          <a:lnRef idx="1">
+            <a:schemeClr val="accent1"/>
+          </a:lnRef>
+          <a:fillRef idx="3">
+            <a:schemeClr val="accent1"/>
+          </a:fillRef>
+          <a:effectRef idx="2">
+            <a:schemeClr val="accent1"/>
+          </a:effectRef>
+          <a:fontRef idx="minor">
+            <a:schemeClr val="lt1"/>
+          </a:fontRef>
+        </p:style>
+        <p:txBody>
+          <a:bodyPr rtlCol="0" anchor="ctr"/>
+          <a:lstStyle/>
+          <a:p>
+            <a:pPr algn="ctr"/>
+          </a:p>
+        </p:txBody>
+      </p:sp>
+      <p:sp>
+        <p:nvSpPr>
+          <p:cNvPr id="7" name="TextBox 6"/>
+          <p:cNvSpPr txBox="1"/>
+          <p:nvPr/>
+        </p:nvSpPr>
+        <p:spPr>
+          <a:xfrm>
+            <a:off x="813816" y="502920"/>
+            <a:ext cx="10634472" cy="685800"/>
+          </a:xfrm>
+          <a:prstGeom prst="rect">
+            <a:avLst/>
+          </a:prstGeom>
+          <a:noFill/>
+        </p:spPr>
+        <p:txBody>
+          <a:bodyPr wrap="square">
+            <a:spAutoFit/>
+          </a:bodyPr>
+          <a:lstStyle/>
+          <a:p>
+            <a:pPr algn="l"/>
+            <a:r>
+              <a:rPr sz="2400" b="1" i="0">
+                <a:solidFill>
+                  <a:srgbClr val="1F2C56"/>
+                </a:solidFill>
+                <a:latin typeface="Arial"/>
+              </a:rPr>
+              <a:t>Praxisfall bearbeiten: Vorgänge in agree</a:t>
+            </a:r>
+          </a:p>
+        </p:txBody>
+      </p:sp>
+      <p:sp>
+        <p:nvSpPr>
+          <p:cNvPr id="8" name="TextBox 7"/>
+          <p:cNvSpPr txBox="1"/>
+          <p:nvPr/>
+        </p:nvSpPr>
+        <p:spPr>
+          <a:xfrm>
+            <a:off x="685800" y="1554480"/>
+            <a:ext cx="10817352" cy="3840480"/>
+          </a:xfrm>
+          <a:prstGeom prst="rect">
+            <a:avLst/>
+          </a:prstGeom>
+          <a:noFill/>
+        </p:spPr>
+        <p:txBody>
+          <a:bodyPr wrap="square">
+            <a:spAutoFit/>
+          </a:bodyPr>
+          <a:lstStyle/>
+          <a:p>
+            <a:pPr marL="190500" indent="-190500">
+              <a:spcBef>
+                <a:spcPts val="400"/>
+              </a:spcBef>
+              <a:spcAft>
+                <a:spcPts val="200"/>
+              </a:spcAft>
+            </a:pPr>
+            <a:r>
+              <a:rPr sz="1400">
+                <a:solidFill>
+                  <a:srgbClr val="3D5466"/>
+                </a:solidFill>
+                <a:latin typeface="Arial"/>
+              </a:rPr>
+              <a:t>▸  Ordnen Sie die drei Vorgänge den Funktionsbereichen zu, bevor Sie das System öffnen (AB-1).</a:t>
+            </a:r>
+          </a:p>
+          <a:p>
+            <a:pPr marL="190500" indent="-190500">
+              <a:spcBef>
+                <a:spcPts val="400"/>
+              </a:spcBef>
+              <a:spcAft>
+                <a:spcPts val="200"/>
+              </a:spcAft>
+            </a:pPr>
+            <a:r>
+              <a:rPr sz="1400">
+                <a:solidFill>
+                  <a:srgbClr val="3D5466"/>
+                </a:solidFill>
+                <a:latin typeface="Arial"/>
+              </a:rPr>
+              <a:t>▸  Bearbeiten Sie die Beraternachfrage („Liegt der aktuelle Sicherheitenvertrag vor?") vollständig in agree (AB-2).</a:t>
+            </a:r>
+          </a:p>
+          <a:p>
+            <a:pPr marL="190500" indent="-190500">
+              <a:spcBef>
+                <a:spcPts val="400"/>
+              </a:spcBef>
+              <a:spcAft>
+                <a:spcPts val="200"/>
+              </a:spcAft>
+            </a:pPr>
+            <a:r>
+              <a:rPr sz="1400">
+                <a:solidFill>
+                  <a:srgbClr val="3D5466"/>
+                </a:solidFill>
+                <a:latin typeface="Arial"/>
+              </a:rPr>
+              <a:t>▸  Notieren Sie zwei eigene Workarounds mit Risiko und agree-Lösung (AB-3).</a:t>
+            </a:r>
+          </a:p>
+          <a:p>
+            <a:pPr marL="190500" indent="-190500">
+              <a:spcBef>
+                <a:spcPts val="400"/>
+              </a:spcBef>
+              <a:spcAft>
+                <a:spcPts val="200"/>
+              </a:spcAft>
+            </a:pPr>
+            <a:r>
+              <a:rPr sz="1400">
+                <a:solidFill>
+                  <a:srgbClr val="3D5466"/>
+                </a:solidFill>
+                <a:latin typeface="Arial"/>
+              </a:rPr>
+              <a:t>▸  Erfassen Sie die Adressänderung und legen Sie für die fehlende BWA eine Wiedervorlage an (AB-4).</a:t>
+            </a:r>
+          </a:p>
+        </p:txBody>
+      </p:sp>
+      <p:sp>
+        <p:nvSpPr>
+          <p:cNvPr id="9" name="Rectangle 8"/>
+          <p:cNvSpPr/>
+          <p:nvPr/>
+        </p:nvSpPr>
+        <p:spPr>
+          <a:xfrm>
+            <a:off x="685800" y="5486400"/>
+            <a:ext cx="10817352" cy="640080"/>
+          </a:xfrm>
+          <a:prstGeom prst="rect">
+            <a:avLst/>
+          </a:prstGeom>
+          <a:solidFill>
+            <a:srgbClr val="1F2C56"/>
+          </a:solidFill>
+          <a:ln>
+            <a:noFill/>
+          </a:ln>
+        </p:spPr>
+        <p:style>
+          <a:lnRef idx="1">
+            <a:schemeClr val="accent1"/>
+          </a:lnRef>
+          <a:fillRef idx="3">
+            <a:schemeClr val="accent1"/>
+          </a:fillRef>
+          <a:effectRef idx="2">
+            <a:schemeClr val="accent1"/>
+          </a:effectRef>
+          <a:fontRef idx="minor">
+            <a:schemeClr val="lt1"/>
+          </a:fontRef>
+        </p:style>
+        <p:txBody>
+          <a:bodyPr rtlCol="0" anchor="ctr"/>
+          <a:lstStyle/>
+          <a:p>
+            <a:pPr algn="ctr"/>
+          </a:p>
+        </p:txBody>
+      </p:sp>
+      <p:sp>
+        <p:nvSpPr>
+          <p:cNvPr id="10" name="TextBox 9"/>
+          <p:cNvSpPr txBox="1"/>
+          <p:nvPr/>
+        </p:nvSpPr>
+        <p:spPr>
+          <a:xfrm>
+            <a:off x="868680" y="5596128"/>
+            <a:ext cx="10451592" cy="457200"/>
+          </a:xfrm>
+          <a:prstGeom prst="rect">
+            <a:avLst/>
+          </a:prstGeom>
+          <a:noFill/>
+        </p:spPr>
+        <p:txBody>
+          <a:bodyPr wrap="square">
+            <a:spAutoFit/>
+          </a:bodyPr>
+          <a:lstStyle/>
+          <a:p>
+            <a:pPr algn="l"/>
+            <a:r>
+              <a:rPr sz="1300" b="1" i="0">
+                <a:solidFill>
+                  <a:srgbClr val="FFFFFF"/>
+                </a:solidFill>
+                <a:latin typeface="Arial"/>
+              </a:rPr>
+              <a:t>→  Bearbeitung im Teilnehmer-Workbook (Arbeitsblatt mit Ausfüllfeldern)</a:t>
+            </a:r>
+          </a:p>
+        </p:txBody>
+      </p:sp>
+      <p:sp>
+        <p:nvSpPr>
+          <p:cNvPr id="11" name="Rectangle 10"/>
+          <p:cNvSpPr/>
+          <p:nvPr/>
+        </p:nvSpPr>
+        <p:spPr>
+          <a:xfrm>
+            <a:off x="0" y="6510528"/>
+            <a:ext cx="12188952" cy="347472"/>
+          </a:xfrm>
+          <a:prstGeom prst="rect">
+            <a:avLst/>
+          </a:prstGeom>
+          <a:solidFill>
+            <a:srgbClr val="0A1937"/>
+          </a:solidFill>
+          <a:ln>
+            <a:noFill/>
+          </a:ln>
+        </p:spPr>
+        <p:style>
+          <a:lnRef idx="1">
+            <a:schemeClr val="accent1"/>
+          </a:lnRef>
+          <a:fillRef idx="3">
+            <a:schemeClr val="accent1"/>
+          </a:fillRef>
+          <a:effectRef idx="2">
+            <a:schemeClr val="accent1"/>
+          </a:effectRef>
+          <a:fontRef idx="minor">
+            <a:schemeClr val="lt1"/>
+          </a:fontRef>
+        </p:style>
+        <p:txBody>
+          <a:bodyPr rtlCol="0" anchor="ctr"/>
+          <a:lstStyle/>
+          <a:p>
+            <a:pPr algn="ctr"/>
+          </a:p>
+        </p:txBody>
+      </p:sp>
+      <p:sp>
+        <p:nvSpPr>
+          <p:cNvPr id="12" name="TextBox 11"/>
+          <p:cNvSpPr txBox="1"/>
+          <p:nvPr/>
+        </p:nvSpPr>
+        <p:spPr>
+          <a:xfrm>
+            <a:off x="685800" y="6583680"/>
+            <a:ext cx="6490411" cy="256032"/>
+          </a:xfrm>
+          <a:prstGeom prst="rect">
+            <a:avLst/>
+          </a:prstGeom>
+          <a:noFill/>
+        </p:spPr>
+        <p:txBody>
+          <a:bodyPr wrap="none">
+            <a:spAutoFit/>
+          </a:bodyPr>
+          <a:lstStyle/>
+          <a:p>
+            <a:pPr algn="l"/>
+            <a:r>
+              <a:rPr sz="700">
+                <a:solidFill>
+                  <a:srgbClr val="A0B4D2"/>
+                </a:solidFill>
+                <a:latin typeface="Consolas"/>
+              </a:rPr>
+              <a:t>FKB Campus  ·  VA03</a:t>
+            </a:r>
+          </a:p>
+        </p:txBody>
+      </p:sp>
+    </p:spTree>
+  </p:cSld>
+  <p:clrMapOvr>
+    <a:masterClrMapping/>
+  </p:clrMapOvr>
+</p:sld>
+</file>
+
+<file path=ppt/slides/slide15.xml><?xml version="1.0" encoding="utf-8"?>
+<p:sld xmlns:a="http://schemas.openxmlformats.org/drawingml/2006/main" xmlns:p="http://schemas.openxmlformats.org/presentationml/2006/main" xmlns:r="http://schemas.openxmlformats.org/officeDocument/2006/relationships">
+  <p:cSld>
+    <p:spTree>
+      <p:nvGrpSpPr>
+        <p:cNvPr id="1" name=""/>
+        <p:cNvGrpSpPr/>
+        <p:nvPr/>
+      </p:nvGrpSpPr>
+      <p:grpSpPr/>
+      <p:sp>
+        <p:nvSpPr>
+          <p:cNvPr id="2" name="Rectangle 1"/>
+          <p:cNvSpPr/>
+          <p:nvPr/>
+        </p:nvSpPr>
+        <p:spPr>
+          <a:xfrm>
+            <a:off x="0" y="0"/>
+            <a:ext cx="12188952" cy="6858000"/>
+          </a:xfrm>
+          <a:prstGeom prst="rect">
+            <a:avLst/>
+          </a:prstGeom>
+          <a:solidFill>
+            <a:srgbClr val="EDEDF3"/>
+          </a:solidFill>
+          <a:ln>
+            <a:noFill/>
+          </a:ln>
+        </p:spPr>
+        <p:style>
+          <a:lnRef idx="1">
+            <a:schemeClr val="accent1"/>
+          </a:lnRef>
+          <a:fillRef idx="3">
+            <a:schemeClr val="accent1"/>
+          </a:fillRef>
+          <a:effectRef idx="2">
+            <a:schemeClr val="accent1"/>
+          </a:effectRef>
+          <a:fontRef idx="minor">
+            <a:schemeClr val="lt1"/>
+          </a:fontRef>
+        </p:style>
+        <p:txBody>
+          <a:bodyPr rtlCol="0" anchor="ctr"/>
+          <a:lstStyle/>
+          <a:p>
+            <a:pPr algn="ctr"/>
+          </a:p>
+        </p:txBody>
+      </p:sp>
+      <p:sp>
+        <p:nvSpPr>
+          <p:cNvPr id="3" name="Rectangle 2"/>
+          <p:cNvSpPr/>
+          <p:nvPr/>
+        </p:nvSpPr>
+        <p:spPr>
+          <a:xfrm>
+            <a:off x="0" y="0"/>
+            <a:ext cx="12188952" cy="50292"/>
+          </a:xfrm>
+          <a:prstGeom prst="rect">
+            <a:avLst/>
+          </a:prstGeom>
+          <a:solidFill>
+            <a:srgbClr val="1F2C56"/>
+          </a:solidFill>
+          <a:ln>
+            <a:noFill/>
+          </a:ln>
+        </p:spPr>
+        <p:style>
+          <a:lnRef idx="1">
+            <a:schemeClr val="accent1"/>
+          </a:lnRef>
+          <a:fillRef idx="3">
+            <a:schemeClr val="accent1"/>
+          </a:fillRef>
+          <a:effectRef idx="2">
+            <a:schemeClr val="accent1"/>
+          </a:effectRef>
+          <a:fontRef idx="minor">
+            <a:schemeClr val="lt1"/>
+          </a:fontRef>
+        </p:style>
+        <p:txBody>
+          <a:bodyPr rtlCol="0" anchor="ctr"/>
+          <a:lstStyle/>
+          <a:p>
+            <a:pPr algn="ctr"/>
+          </a:p>
+        </p:txBody>
+      </p:sp>
+      <p:sp>
+        <p:nvSpPr>
+          <p:cNvPr id="4" name="TextBox 3"/>
+          <p:cNvSpPr txBox="1"/>
+          <p:nvPr/>
+        </p:nvSpPr>
+        <p:spPr>
+          <a:xfrm>
+            <a:off x="685800" y="109728"/>
+            <a:ext cx="10817352" cy="228600"/>
+          </a:xfrm>
+          <a:prstGeom prst="rect">
+            <a:avLst/>
+          </a:prstGeom>
+          <a:noFill/>
+        </p:spPr>
+        <p:txBody>
+          <a:bodyPr wrap="none">
+            <a:spAutoFit/>
+          </a:bodyPr>
+          <a:lstStyle/>
+          <a:p>
+            <a:pPr algn="l"/>
+            <a:r>
+              <a:rPr sz="750">
+                <a:solidFill>
+                  <a:srgbClr val="78808C"/>
+                </a:solidFill>
+                <a:latin typeface="Consolas"/>
+              </a:rPr>
+              <a:t>VA03  ·  INHALT</a:t>
+            </a:r>
+          </a:p>
+        </p:txBody>
+      </p:sp>
+      <p:sp>
+        <p:nvSpPr>
+          <p:cNvPr id="5" name="Rectangle 4"/>
+          <p:cNvSpPr/>
+          <p:nvPr/>
+        </p:nvSpPr>
+        <p:spPr>
+          <a:xfrm>
+            <a:off x="0" y="1234440"/>
+            <a:ext cx="12188952" cy="12700"/>
+          </a:xfrm>
+          <a:prstGeom prst="rect">
+            <a:avLst/>
+          </a:prstGeom>
+          <a:solidFill>
+            <a:srgbClr val="D8DFE4"/>
+          </a:solidFill>
+          <a:ln>
+            <a:noFill/>
+          </a:ln>
+        </p:spPr>
+        <p:style>
+          <a:lnRef idx="1">
+            <a:schemeClr val="accent1"/>
+          </a:lnRef>
+          <a:fillRef idx="3">
+            <a:schemeClr val="accent1"/>
+          </a:fillRef>
+          <a:effectRef idx="2">
+            <a:schemeClr val="accent1"/>
+          </a:effectRef>
+          <a:fontRef idx="minor">
+            <a:schemeClr val="lt1"/>
+          </a:fontRef>
+        </p:style>
+        <p:txBody>
+          <a:bodyPr rtlCol="0" anchor="ctr"/>
+          <a:lstStyle/>
+          <a:p>
+            <a:pPr algn="ctr"/>
+          </a:p>
+        </p:txBody>
+      </p:sp>
+      <p:sp>
+        <p:nvSpPr>
+          <p:cNvPr id="6" name="Rectangle 5"/>
+          <p:cNvSpPr/>
+          <p:nvPr/>
+        </p:nvSpPr>
+        <p:spPr>
+          <a:xfrm>
+            <a:off x="685800" y="502920"/>
+            <a:ext cx="36576" cy="658368"/>
+          </a:xfrm>
+          <a:prstGeom prst="rect">
+            <a:avLst/>
+          </a:prstGeom>
+          <a:solidFill>
+            <a:srgbClr val="D9C089"/>
+          </a:solidFill>
+          <a:ln>
+            <a:noFill/>
+          </a:ln>
+        </p:spPr>
+        <p:style>
+          <a:lnRef idx="1">
+            <a:schemeClr val="accent1"/>
+          </a:lnRef>
+          <a:fillRef idx="3">
+            <a:schemeClr val="accent1"/>
+          </a:fillRef>
+          <a:effectRef idx="2">
+            <a:schemeClr val="accent1"/>
+          </a:effectRef>
+          <a:fontRef idx="minor">
+            <a:schemeClr val="lt1"/>
+          </a:fontRef>
+        </p:style>
+        <p:txBody>
+          <a:bodyPr rtlCol="0" anchor="ctr"/>
+          <a:lstStyle/>
+          <a:p>
+            <a:pPr algn="ctr"/>
+          </a:p>
+        </p:txBody>
+      </p:sp>
+      <p:sp>
+        <p:nvSpPr>
+          <p:cNvPr id="7" name="TextBox 6"/>
+          <p:cNvSpPr txBox="1"/>
+          <p:nvPr/>
+        </p:nvSpPr>
+        <p:spPr>
+          <a:xfrm>
+            <a:off x="813816" y="502920"/>
+            <a:ext cx="10634472" cy="685800"/>
+          </a:xfrm>
+          <a:prstGeom prst="rect">
+            <a:avLst/>
+          </a:prstGeom>
+          <a:noFill/>
+        </p:spPr>
+        <p:txBody>
+          <a:bodyPr wrap="square">
+            <a:spAutoFit/>
+          </a:bodyPr>
+          <a:lstStyle/>
+          <a:p>
+            <a:pPr algn="l"/>
+            <a:r>
+              <a:rPr sz="2400" b="1" i="0">
+                <a:solidFill>
+                  <a:srgbClr val="1F2C56"/>
+                </a:solidFill>
+                <a:latin typeface="Arial"/>
+              </a:rPr>
+              <a:t>Prinzip dieses Moduls</a:t>
+            </a:r>
+          </a:p>
+        </p:txBody>
+      </p:sp>
+      <p:sp>
+        <p:nvSpPr>
+          <p:cNvPr id="8" name="TextBox 7"/>
+          <p:cNvSpPr txBox="1"/>
+          <p:nvPr/>
+        </p:nvSpPr>
+        <p:spPr>
+          <a:xfrm>
+            <a:off x="685800" y="1417320"/>
+            <a:ext cx="10817352" cy="4892040"/>
+          </a:xfrm>
+          <a:prstGeom prst="rect">
+            <a:avLst/>
+          </a:prstGeom>
+          <a:noFill/>
+        </p:spPr>
+        <p:txBody>
+          <a:bodyPr wrap="square" anchor="ctr">
+            <a:spAutoFit/>
+          </a:bodyPr>
+          <a:lstStyle/>
+          <a:p>
+            <a:pPr marL="177800" indent="-177800">
+              <a:spcBef>
+                <a:spcPts val="600"/>
+              </a:spcBef>
+              <a:spcAft>
+                <a:spcPts val="200"/>
+              </a:spcAft>
+            </a:pPr>
+            <a:r>
+              <a:rPr sz="1200" i="1">
+                <a:solidFill>
+                  <a:srgbClr val="3D5466"/>
+                </a:solidFill>
+                <a:latin typeface="Arial"/>
+              </a:rPr>
+              <a:t>→  Jeder Workaround ist ein verstecktes Risiko.</a:t>
+            </a:r>
+          </a:p>
+          <a:p>
+            <a:pPr marL="190500" indent="-190500">
+              <a:spcBef>
+                <a:spcPts val="400"/>
+              </a:spcBef>
+              <a:spcAft>
+                <a:spcPts val="200"/>
+              </a:spcAft>
+            </a:pPr>
+            <a:r>
+              <a:rPr sz="1300">
+                <a:solidFill>
+                  <a:srgbClr val="3D5466"/>
+                </a:solidFill>
+                <a:latin typeface="Arial"/>
+              </a:rPr>
+              <a:t>▸  Excel-Listen und Notizzettel umgehen das System – wer den Vorgang in agree führt, macht ihn nachvollziehbar und prüfsicher.</a:t>
+            </a:r>
+          </a:p>
+        </p:txBody>
+      </p:sp>
+      <p:sp>
+        <p:nvSpPr>
+          <p:cNvPr id="9" name="Rectangle 8"/>
+          <p:cNvSpPr/>
+          <p:nvPr/>
+        </p:nvSpPr>
+        <p:spPr>
+          <a:xfrm>
+            <a:off x="0" y="6510528"/>
+            <a:ext cx="12188952" cy="347472"/>
+          </a:xfrm>
+          <a:prstGeom prst="rect">
+            <a:avLst/>
+          </a:prstGeom>
+          <a:solidFill>
+            <a:srgbClr val="0A1937"/>
+          </a:solidFill>
+          <a:ln>
+            <a:noFill/>
+          </a:ln>
+        </p:spPr>
+        <p:style>
+          <a:lnRef idx="1">
+            <a:schemeClr val="accent1"/>
+          </a:lnRef>
+          <a:fillRef idx="3">
+            <a:schemeClr val="accent1"/>
+          </a:fillRef>
+          <a:effectRef idx="2">
+            <a:schemeClr val="accent1"/>
+          </a:effectRef>
+          <a:fontRef idx="minor">
+            <a:schemeClr val="lt1"/>
+          </a:fontRef>
+        </p:style>
+        <p:txBody>
+          <a:bodyPr rtlCol="0" anchor="ctr"/>
+          <a:lstStyle/>
+          <a:p>
+            <a:pPr algn="ctr"/>
+          </a:p>
+        </p:txBody>
+      </p:sp>
+      <p:sp>
+        <p:nvSpPr>
+          <p:cNvPr id="10" name="TextBox 9"/>
+          <p:cNvSpPr txBox="1"/>
+          <p:nvPr/>
+        </p:nvSpPr>
+        <p:spPr>
+          <a:xfrm>
+            <a:off x="685800" y="6583680"/>
+            <a:ext cx="6490411" cy="256032"/>
+          </a:xfrm>
+          <a:prstGeom prst="rect">
+            <a:avLst/>
+          </a:prstGeom>
+          <a:noFill/>
+        </p:spPr>
+        <p:txBody>
+          <a:bodyPr wrap="none">
+            <a:spAutoFit/>
+          </a:bodyPr>
+          <a:lstStyle/>
+          <a:p>
+            <a:pPr algn="l"/>
+            <a:r>
+              <a:rPr sz="700">
+                <a:solidFill>
+                  <a:srgbClr val="A0B4D2"/>
+                </a:solidFill>
+                <a:latin typeface="Consolas"/>
+              </a:rPr>
+              <a:t>FKB Campus  ·  VA03</a:t>
+            </a:r>
+          </a:p>
+        </p:txBody>
+      </p:sp>
+    </p:spTree>
+  </p:cSld>
+  <p:clrMapOvr>
+    <a:masterClrMapping/>
+  </p:clrMapOvr>
+</p:sld>
+</file>
+
+<file path=ppt/slides/slide16.xml><?xml version="1.0" encoding="utf-8"?>
+<p:sld xmlns:a="http://schemas.openxmlformats.org/drawingml/2006/main" xmlns:p="http://schemas.openxmlformats.org/presentationml/2006/main" xmlns:r="http://schemas.openxmlformats.org/officeDocument/2006/relationships">
+  <p:cSld>
+    <p:spTree>
+      <p:nvGrpSpPr>
+        <p:cNvPr id="1" name=""/>
+        <p:cNvGrpSpPr/>
+        <p:nvPr/>
+      </p:nvGrpSpPr>
+      <p:grpSpPr/>
+      <p:sp>
+        <p:nvSpPr>
+          <p:cNvPr id="2" name="Rectangle 1"/>
+          <p:cNvSpPr/>
+          <p:nvPr/>
+        </p:nvSpPr>
+        <p:spPr>
+          <a:xfrm>
+            <a:off x="0" y="0"/>
+            <a:ext cx="12188952" cy="6858000"/>
+          </a:xfrm>
+          <a:prstGeom prst="rect">
+            <a:avLst/>
+          </a:prstGeom>
+          <a:solidFill>
+            <a:srgbClr val="EDEDF3"/>
+          </a:solidFill>
+          <a:ln>
+            <a:noFill/>
+          </a:ln>
+        </p:spPr>
+        <p:style>
+          <a:lnRef idx="1">
+            <a:schemeClr val="accent1"/>
+          </a:lnRef>
+          <a:fillRef idx="3">
+            <a:schemeClr val="accent1"/>
+          </a:fillRef>
+          <a:effectRef idx="2">
+            <a:schemeClr val="accent1"/>
+          </a:effectRef>
+          <a:fontRef idx="minor">
+            <a:schemeClr val="lt1"/>
+          </a:fontRef>
+        </p:style>
+        <p:txBody>
+          <a:bodyPr rtlCol="0" anchor="ctr"/>
+          <a:lstStyle/>
+          <a:p>
+            <a:pPr algn="ctr"/>
+          </a:p>
+        </p:txBody>
+      </p:sp>
+      <p:sp>
+        <p:nvSpPr>
+          <p:cNvPr id="3" name="Rectangle 2"/>
+          <p:cNvSpPr/>
+          <p:nvPr/>
+        </p:nvSpPr>
+        <p:spPr>
+          <a:xfrm>
+            <a:off x="0" y="0"/>
+            <a:ext cx="12188952" cy="50292"/>
+          </a:xfrm>
+          <a:prstGeom prst="rect">
+            <a:avLst/>
+          </a:prstGeom>
+          <a:solidFill>
+            <a:srgbClr val="1F2C56"/>
+          </a:solidFill>
+          <a:ln>
+            <a:noFill/>
+          </a:ln>
+        </p:spPr>
+        <p:style>
+          <a:lnRef idx="1">
+            <a:schemeClr val="accent1"/>
+          </a:lnRef>
+          <a:fillRef idx="3">
+            <a:schemeClr val="accent1"/>
+          </a:fillRef>
+          <a:effectRef idx="2">
+            <a:schemeClr val="accent1"/>
+          </a:effectRef>
+          <a:fontRef idx="minor">
+            <a:schemeClr val="lt1"/>
+          </a:fontRef>
+        </p:style>
+        <p:txBody>
+          <a:bodyPr rtlCol="0" anchor="ctr"/>
+          <a:lstStyle/>
+          <a:p>
+            <a:pPr algn="ctr"/>
+          </a:p>
+        </p:txBody>
+      </p:sp>
+      <p:sp>
+        <p:nvSpPr>
+          <p:cNvPr id="4" name="TextBox 3"/>
+          <p:cNvSpPr txBox="1"/>
+          <p:nvPr/>
+        </p:nvSpPr>
+        <p:spPr>
+          <a:xfrm>
+            <a:off x="685800" y="109728"/>
+            <a:ext cx="10817352" cy="228600"/>
+          </a:xfrm>
+          <a:prstGeom prst="rect">
+            <a:avLst/>
+          </a:prstGeom>
+          <a:noFill/>
+        </p:spPr>
+        <p:txBody>
+          <a:bodyPr wrap="none">
+            <a:spAutoFit/>
+          </a:bodyPr>
+          <a:lstStyle/>
+          <a:p>
+            <a:pPr algn="l"/>
+            <a:r>
+              <a:rPr sz="750">
+                <a:solidFill>
+                  <a:srgbClr val="78808C"/>
+                </a:solidFill>
+                <a:latin typeface="Consolas"/>
+              </a:rPr>
+              <a:t>VA03  ·  INHALT</a:t>
+            </a:r>
+          </a:p>
+        </p:txBody>
+      </p:sp>
+      <p:sp>
+        <p:nvSpPr>
+          <p:cNvPr id="5" name="Rectangle 4"/>
+          <p:cNvSpPr/>
+          <p:nvPr/>
+        </p:nvSpPr>
+        <p:spPr>
+          <a:xfrm>
+            <a:off x="0" y="1234440"/>
+            <a:ext cx="12188952" cy="12700"/>
+          </a:xfrm>
+          <a:prstGeom prst="rect">
+            <a:avLst/>
+          </a:prstGeom>
+          <a:solidFill>
+            <a:srgbClr val="D8DFE4"/>
+          </a:solidFill>
+          <a:ln>
+            <a:noFill/>
+          </a:ln>
+        </p:spPr>
+        <p:style>
+          <a:lnRef idx="1">
+            <a:schemeClr val="accent1"/>
+          </a:lnRef>
+          <a:fillRef idx="3">
+            <a:schemeClr val="accent1"/>
+          </a:fillRef>
+          <a:effectRef idx="2">
+            <a:schemeClr val="accent1"/>
+          </a:effectRef>
+          <a:fontRef idx="minor">
+            <a:schemeClr val="lt1"/>
+          </a:fontRef>
+        </p:style>
+        <p:txBody>
+          <a:bodyPr rtlCol="0" anchor="ctr"/>
+          <a:lstStyle/>
+          <a:p>
+            <a:pPr algn="ctr"/>
+          </a:p>
+        </p:txBody>
+      </p:sp>
+      <p:sp>
+        <p:nvSpPr>
+          <p:cNvPr id="6" name="Rectangle 5"/>
+          <p:cNvSpPr/>
+          <p:nvPr/>
+        </p:nvSpPr>
+        <p:spPr>
+          <a:xfrm>
+            <a:off x="685800" y="502920"/>
+            <a:ext cx="36576" cy="658368"/>
+          </a:xfrm>
+          <a:prstGeom prst="rect">
+            <a:avLst/>
+          </a:prstGeom>
+          <a:solidFill>
+            <a:srgbClr val="D9C089"/>
+          </a:solidFill>
+          <a:ln>
+            <a:noFill/>
+          </a:ln>
+        </p:spPr>
+        <p:style>
+          <a:lnRef idx="1">
+            <a:schemeClr val="accent1"/>
+          </a:lnRef>
+          <a:fillRef idx="3">
+            <a:schemeClr val="accent1"/>
+          </a:fillRef>
+          <a:effectRef idx="2">
+            <a:schemeClr val="accent1"/>
+          </a:effectRef>
+          <a:fontRef idx="minor">
+            <a:schemeClr val="lt1"/>
+          </a:fontRef>
+        </p:style>
+        <p:txBody>
+          <a:bodyPr rtlCol="0" anchor="ctr"/>
+          <a:lstStyle/>
+          <a:p>
+            <a:pPr algn="ctr"/>
+          </a:p>
+        </p:txBody>
+      </p:sp>
+      <p:sp>
+        <p:nvSpPr>
+          <p:cNvPr id="7" name="TextBox 6"/>
+          <p:cNvSpPr txBox="1"/>
+          <p:nvPr/>
+        </p:nvSpPr>
+        <p:spPr>
+          <a:xfrm>
+            <a:off x="813816" y="502920"/>
+            <a:ext cx="10634472" cy="685800"/>
+          </a:xfrm>
+          <a:prstGeom prst="rect">
+            <a:avLst/>
+          </a:prstGeom>
+          <a:noFill/>
+        </p:spPr>
+        <p:txBody>
+          <a:bodyPr wrap="square">
+            <a:spAutoFit/>
+          </a:bodyPr>
+          <a:lstStyle/>
+          <a:p>
+            <a:pPr algn="l"/>
+            <a:r>
+              <a:rPr sz="2400" b="1" i="0">
+                <a:solidFill>
+                  <a:srgbClr val="1F2C56"/>
+                </a:solidFill>
+                <a:latin typeface="Arial"/>
+              </a:rPr>
+              <a:t>Reflexionsfragen</a:t>
+            </a:r>
+          </a:p>
+        </p:txBody>
+      </p:sp>
+      <p:sp>
+        <p:nvSpPr>
+          <p:cNvPr id="8" name="TextBox 7"/>
+          <p:cNvSpPr txBox="1"/>
+          <p:nvPr/>
+        </p:nvSpPr>
+        <p:spPr>
+          <a:xfrm>
+            <a:off x="685800" y="1417320"/>
+            <a:ext cx="10817352" cy="4892040"/>
+          </a:xfrm>
+          <a:prstGeom prst="rect">
+            <a:avLst/>
+          </a:prstGeom>
+          <a:noFill/>
+        </p:spPr>
+        <p:txBody>
+          <a:bodyPr wrap="square" anchor="ctr">
+            <a:spAutoFit/>
+          </a:bodyPr>
+          <a:lstStyle/>
+          <a:p>
+            <a:pPr marL="190500" indent="-190500">
+              <a:spcBef>
+                <a:spcPts val="400"/>
+              </a:spcBef>
+              <a:spcAft>
+                <a:spcPts val="200"/>
+              </a:spcAft>
+            </a:pPr>
+            <a:r>
+              <a:rPr sz="1300">
+                <a:solidFill>
+                  <a:srgbClr val="3D5466"/>
+                </a:solidFill>
+                <a:latin typeface="Arial"/>
+              </a:rPr>
+              <a:t>▸  Welchen Workaround nutzen Sie am häufigsten – und welches Problem löst er, das agree (noch) nicht löst?</a:t>
+            </a:r>
+          </a:p>
+          <a:p>
+            <a:pPr marL="190500" indent="-190500">
+              <a:spcBef>
+                <a:spcPts val="400"/>
+              </a:spcBef>
+              <a:spcAft>
+                <a:spcPts val="200"/>
+              </a:spcAft>
+            </a:pPr>
+            <a:r>
+              <a:rPr sz="1300">
+                <a:solidFill>
+                  <a:srgbClr val="3D5466"/>
+                </a:solidFill>
+                <a:latin typeface="Arial"/>
+              </a:rPr>
+              <a:t>▸  Woran erkennen Sie, dass eine Information ins System gehört und nicht auf einen Notizzettel?</a:t>
+            </a:r>
+          </a:p>
+          <a:p>
+            <a:pPr marL="190500" indent="-190500">
+              <a:spcBef>
+                <a:spcPts val="400"/>
+              </a:spcBef>
+              <a:spcAft>
+                <a:spcPts val="200"/>
+              </a:spcAft>
+            </a:pPr>
+            <a:r>
+              <a:rPr sz="1300">
+                <a:solidFill>
+                  <a:srgbClr val="3D5466"/>
+                </a:solidFill>
+                <a:latin typeface="Arial"/>
+              </a:rPr>
+              <a:t>▸  Wie würden Sie einer neuen Kollegin erklären, warum die Excel-Liste ein Risiko ist?</a:t>
+            </a:r>
+          </a:p>
+        </p:txBody>
+      </p:sp>
+      <p:sp>
+        <p:nvSpPr>
+          <p:cNvPr id="9" name="Rectangle 8"/>
+          <p:cNvSpPr/>
+          <p:nvPr/>
+        </p:nvSpPr>
+        <p:spPr>
+          <a:xfrm>
+            <a:off x="0" y="6510528"/>
+            <a:ext cx="12188952" cy="347472"/>
+          </a:xfrm>
+          <a:prstGeom prst="rect">
+            <a:avLst/>
+          </a:prstGeom>
+          <a:solidFill>
+            <a:srgbClr val="0A1937"/>
+          </a:solidFill>
+          <a:ln>
+            <a:noFill/>
+          </a:ln>
+        </p:spPr>
+        <p:style>
+          <a:lnRef idx="1">
+            <a:schemeClr val="accent1"/>
+          </a:lnRef>
+          <a:fillRef idx="3">
+            <a:schemeClr val="accent1"/>
+          </a:fillRef>
+          <a:effectRef idx="2">
+            <a:schemeClr val="accent1"/>
+          </a:effectRef>
+          <a:fontRef idx="minor">
+            <a:schemeClr val="lt1"/>
+          </a:fontRef>
+        </p:style>
+        <p:txBody>
+          <a:bodyPr rtlCol="0" anchor="ctr"/>
+          <a:lstStyle/>
+          <a:p>
+            <a:pPr algn="ctr"/>
+          </a:p>
+        </p:txBody>
+      </p:sp>
+      <p:sp>
+        <p:nvSpPr>
+          <p:cNvPr id="10" name="TextBox 9"/>
+          <p:cNvSpPr txBox="1"/>
+          <p:nvPr/>
+        </p:nvSpPr>
+        <p:spPr>
+          <a:xfrm>
+            <a:off x="685800" y="6583680"/>
+            <a:ext cx="6490411" cy="256032"/>
+          </a:xfrm>
+          <a:prstGeom prst="rect">
+            <a:avLst/>
+          </a:prstGeom>
+          <a:noFill/>
+        </p:spPr>
+        <p:txBody>
+          <a:bodyPr wrap="none">
+            <a:spAutoFit/>
+          </a:bodyPr>
+          <a:lstStyle/>
+          <a:p>
+            <a:pPr algn="l"/>
+            <a:r>
+              <a:rPr sz="700">
+                <a:solidFill>
+                  <a:srgbClr val="A0B4D2"/>
+                </a:solidFill>
+                <a:latin typeface="Consolas"/>
+              </a:rPr>
+              <a:t>FKB Campus  ·  VA03</a:t>
+            </a:r>
+          </a:p>
+        </p:txBody>
+      </p:sp>
+    </p:spTree>
+  </p:cSld>
+  <p:clrMapOvr>
+    <a:masterClrMapping/>
+  </p:clrMapOvr>
+</p:sld>
+</file>
+
 <file path=ppt/slides/slide2.xml><?xml version="1.0" encoding="utf-8"?>
 <p:sld xmlns:a="http://schemas.openxmlformats.org/drawingml/2006/main" xmlns:p="http://schemas.openxmlformats.org/presentationml/2006/main" xmlns:r="http://schemas.openxmlformats.org/officeDocument/2006/relationships">
   <p:cSld>
@@ -5872,7 +8954,7 @@
             <a:avLst/>
           </a:prstGeom>
           <a:solidFill>
-            <a:srgbClr val="EDEDF3"/>
+            <a:srgbClr val="1F2C56"/>
           </a:solidFill>
           <a:ln>
             <a:noFill/>
@@ -5902,57 +8984,14 @@
       </p:sp>
       <p:sp>
         <p:nvSpPr>
-          <p:cNvPr id="3" name="Rectangle 2"/>
-          <p:cNvSpPr/>
-          <p:nvPr/>
-        </p:nvSpPr>
-        <p:spPr>
-          <a:xfrm>
-            <a:off x="0" y="0"/>
-            <a:ext cx="12188952" cy="50292"/>
-          </a:xfrm>
-          <a:prstGeom prst="rect">
-            <a:avLst/>
-          </a:prstGeom>
-          <a:solidFill>
-            <a:srgbClr val="1F2C56"/>
-          </a:solidFill>
-          <a:ln>
-            <a:noFill/>
-          </a:ln>
-        </p:spPr>
-        <p:style>
-          <a:lnRef idx="1">
-            <a:schemeClr val="accent1"/>
-          </a:lnRef>
-          <a:fillRef idx="3">
-            <a:schemeClr val="accent1"/>
-          </a:fillRef>
-          <a:effectRef idx="2">
-            <a:schemeClr val="accent1"/>
-          </a:effectRef>
-          <a:fontRef idx="minor">
-            <a:schemeClr val="lt1"/>
-          </a:fontRef>
-        </p:style>
-        <p:txBody>
-          <a:bodyPr rtlCol="0" anchor="ctr"/>
-          <a:lstStyle/>
-          <a:p>
-            <a:pPr algn="ctr"/>
-          </a:p>
-        </p:txBody>
-      </p:sp>
-      <p:sp>
-        <p:nvSpPr>
-          <p:cNvPr id="4" name="TextBox 3"/>
+          <p:cNvPr id="3" name="TextBox 2"/>
           <p:cNvSpPr txBox="1"/>
           <p:nvPr/>
         </p:nvSpPr>
         <p:spPr>
           <a:xfrm>
-            <a:off x="685800" y="109728"/>
-            <a:ext cx="10817352" cy="228600"/>
+            <a:off x="685800" y="2377440"/>
+            <a:ext cx="10817352" cy="365760"/>
           </a:xfrm>
           <a:prstGeom prst="rect">
             <a:avLst/>
@@ -5967,70 +9006,27 @@
           <a:p>
             <a:pPr algn="l"/>
             <a:r>
-              <a:rPr sz="750">
-                <a:solidFill>
-                  <a:srgbClr val="78808C"/>
+              <a:rPr sz="1200">
+                <a:solidFill>
+                  <a:srgbClr val="D9C089"/>
                 </a:solidFill>
                 <a:latin typeface="Consolas"/>
               </a:rPr>
-              <a:t>VA03  ·  INHALT</a:t>
-            </a:r>
-          </a:p>
-        </p:txBody>
-      </p:sp>
-      <p:sp>
-        <p:nvSpPr>
-          <p:cNvPr id="5" name="Rectangle 4"/>
+              <a:t>00:05–00:20</a:t>
+            </a:r>
+          </a:p>
+        </p:txBody>
+      </p:sp>
+      <p:sp>
+        <p:nvSpPr>
+          <p:cNvPr id="4" name="Rectangle 3"/>
           <p:cNvSpPr/>
           <p:nvPr/>
         </p:nvSpPr>
         <p:spPr>
           <a:xfrm>
-            <a:off x="0" y="1234440"/>
-            <a:ext cx="12188952" cy="12700"/>
-          </a:xfrm>
-          <a:prstGeom prst="rect">
-            <a:avLst/>
-          </a:prstGeom>
-          <a:solidFill>
-            <a:srgbClr val="D8DFE4"/>
-          </a:solidFill>
-          <a:ln>
-            <a:noFill/>
-          </a:ln>
-        </p:spPr>
-        <p:style>
-          <a:lnRef idx="1">
-            <a:schemeClr val="accent1"/>
-          </a:lnRef>
-          <a:fillRef idx="3">
-            <a:schemeClr val="accent1"/>
-          </a:fillRef>
-          <a:effectRef idx="2">
-            <a:schemeClr val="accent1"/>
-          </a:effectRef>
-          <a:fontRef idx="minor">
-            <a:schemeClr val="lt1"/>
-          </a:fontRef>
-        </p:style>
-        <p:txBody>
-          <a:bodyPr rtlCol="0" anchor="ctr"/>
-          <a:lstStyle/>
-          <a:p>
-            <a:pPr algn="ctr"/>
-          </a:p>
-        </p:txBody>
-      </p:sp>
-      <p:sp>
-        <p:nvSpPr>
-          <p:cNvPr id="6" name="Rectangle 5"/>
-          <p:cNvSpPr/>
-          <p:nvPr/>
-        </p:nvSpPr>
-        <p:spPr>
-          <a:xfrm>
-            <a:off x="685800" y="502920"/>
-            <a:ext cx="36576" cy="658368"/>
+            <a:off x="685800" y="2788920"/>
+            <a:ext cx="548640" cy="38100"/>
           </a:xfrm>
           <a:prstGeom prst="rect">
             <a:avLst/>
@@ -6066,14 +9062,14 @@
       </p:sp>
       <p:sp>
         <p:nvSpPr>
-          <p:cNvPr id="7" name="TextBox 6"/>
+          <p:cNvPr id="5" name="TextBox 4"/>
           <p:cNvSpPr txBox="1"/>
           <p:nvPr/>
         </p:nvSpPr>
         <p:spPr>
           <a:xfrm>
-            <a:off x="813816" y="502920"/>
-            <a:ext cx="10634472" cy="685800"/>
+            <a:off x="685800" y="3017520"/>
+            <a:ext cx="10817352" cy="1463040"/>
           </a:xfrm>
           <a:prstGeom prst="rect">
             <a:avLst/>
@@ -6088,27 +9084,27 @@
           <a:p>
             <a:pPr algn="l"/>
             <a:r>
-              <a:rPr sz="2400" b="1" i="0">
-                <a:solidFill>
-                  <a:srgbClr val="1F2C56"/>
+              <a:rPr sz="4000" b="1" i="0">
+                <a:solidFill>
+                  <a:srgbClr val="FFFFFF"/>
                 </a:solidFill>
                 <a:latin typeface="Arial"/>
               </a:rPr>
-              <a:t>Theorie-Input: agree als Single Source of Truth</a:t>
-            </a:r>
-          </a:p>
-        </p:txBody>
-      </p:sp>
-      <p:sp>
-        <p:nvSpPr>
-          <p:cNvPr id="8" name="TextBox 7"/>
+              <a:t>Theorie-Input 1</a:t>
+            </a:r>
+          </a:p>
+        </p:txBody>
+      </p:sp>
+      <p:sp>
+        <p:nvSpPr>
+          <p:cNvPr id="6" name="TextBox 5"/>
           <p:cNvSpPr txBox="1"/>
           <p:nvPr/>
         </p:nvSpPr>
         <p:spPr>
           <a:xfrm>
-            <a:off x="685800" y="1417320"/>
-            <a:ext cx="10817352" cy="4892040"/>
+            <a:off x="685800" y="4480560"/>
+            <a:ext cx="8653881" cy="1280160"/>
           </a:xfrm>
           <a:prstGeom prst="rect">
             <a:avLst/>
@@ -6116,84 +9112,34 @@
           <a:noFill/>
         </p:spPr>
         <p:txBody>
-          <a:bodyPr wrap="square" anchor="ctr">
+          <a:bodyPr wrap="square">
             <a:spAutoFit/>
           </a:bodyPr>
           <a:lstStyle/>
           <a:p>
-            <a:pPr marL="190500" indent="-190500">
-              <a:spcBef>
-                <a:spcPts val="400"/>
-              </a:spcBef>
-              <a:spcAft>
-                <a:spcPts val="200"/>
-              </a:spcAft>
-            </a:pPr>
-            <a:r>
-              <a:rPr sz="1300">
-                <a:solidFill>
-                  <a:srgbClr val="3D5466"/>
+            <a:pPr algn="l"/>
+            <a:r>
+              <a:rPr sz="1600" b="0" i="0">
+                <a:solidFill>
+                  <a:srgbClr val="C8D2E6"/>
                 </a:solidFill>
                 <a:latin typeface="Arial"/>
               </a:rPr>
-              <a:t>▸  agree-Funktionsbereiche für den Innendienst (funktionsorientiert):</a:t>
-            </a:r>
-          </a:p>
-        </p:txBody>
-      </p:sp>
-      <p:sp>
-        <p:nvSpPr>
-          <p:cNvPr id="9" name="Rectangle 8"/>
-          <p:cNvSpPr/>
-          <p:nvPr/>
-        </p:nvSpPr>
-        <p:spPr>
-          <a:xfrm>
-            <a:off x="0" y="6510528"/>
-            <a:ext cx="12188952" cy="347472"/>
-          </a:xfrm>
-          <a:prstGeom prst="rect">
-            <a:avLst/>
-          </a:prstGeom>
-          <a:solidFill>
-            <a:srgbClr val="0A1937"/>
-          </a:solidFill>
-          <a:ln>
-            <a:noFill/>
-          </a:ln>
-        </p:spPr>
-        <p:style>
-          <a:lnRef idx="1">
-            <a:schemeClr val="accent1"/>
-          </a:lnRef>
-          <a:fillRef idx="3">
-            <a:schemeClr val="accent1"/>
-          </a:fillRef>
-          <a:effectRef idx="2">
-            <a:schemeClr val="accent1"/>
-          </a:effectRef>
-          <a:fontRef idx="minor">
-            <a:schemeClr val="lt1"/>
-          </a:fontRef>
-        </p:style>
-        <p:txBody>
-          <a:bodyPr rtlCol="0" anchor="ctr"/>
-          <a:lstStyle/>
-          <a:p>
-            <a:pPr algn="ctr"/>
-          </a:p>
-        </p:txBody>
-      </p:sp>
-      <p:sp>
-        <p:nvSpPr>
-          <p:cNvPr id="10" name="TextBox 9"/>
+              <a:t>agree als eine Wahrheit verstehen – ein Datenpunkt, ein Ort.</a:t>
+            </a:r>
+          </a:p>
+        </p:txBody>
+      </p:sp>
+      <p:sp>
+        <p:nvSpPr>
+          <p:cNvPr id="7" name="TextBox 6"/>
           <p:cNvSpPr txBox="1"/>
           <p:nvPr/>
         </p:nvSpPr>
         <p:spPr>
           <a:xfrm>
-            <a:off x="685800" y="6583680"/>
-            <a:ext cx="6490411" cy="256032"/>
+            <a:off x="685800" y="6355080"/>
+            <a:ext cx="10817352" cy="274320"/>
           </a:xfrm>
           <a:prstGeom prst="rect">
             <a:avLst/>
@@ -6210,7 +9156,7 @@
             <a:r>
               <a:rPr sz="700">
                 <a:solidFill>
-                  <a:srgbClr val="A0B4D2"/>
+                  <a:srgbClr val="8CA0C3"/>
                 </a:solidFill>
                 <a:latin typeface="Consolas"/>
               </a:rPr>
@@ -6474,7 +9420,7 @@
                 </a:solidFill>
                 <a:latin typeface="Arial"/>
               </a:rPr>
-              <a:t>Theorie-Input: Warum Workarounds entstehen – und was sie kosten</a:t>
+              <a:t>agree als Single Source of Truth</a:t>
             </a:r>
           </a:p>
         </p:txBody>
@@ -6500,6 +9446,25 @@
             <a:spAutoFit/>
           </a:bodyPr>
           <a:lstStyle/>
+          <a:p>
+            <a:pPr marL="177800" indent="-177800">
+              <a:spcBef>
+                <a:spcPts val="600"/>
+              </a:spcBef>
+              <a:spcAft>
+                <a:spcPts val="200"/>
+              </a:spcAft>
+            </a:pPr>
+            <a:r>
+              <a:rPr sz="1200" i="1">
+                <a:solidFill>
+                  <a:srgbClr val="3D5466"/>
+                </a:solidFill>
+                <a:latin typeface="Arial"/>
+              </a:rPr>
+              <a:t>→  Ein Datenpunkt – ein Ort. Wer den Vorgang im System führt, macht ihn nachvollziehbar, vertretbar und prüfsicher.</a:t>
+            </a:r>
+          </a:p>
           <a:p>
             <a:pPr marL="190500" indent="-190500">
               <a:spcBef>
@@ -6516,7 +9481,7 @@
                 </a:solidFill>
                 <a:latin typeface="Arial"/>
               </a:rPr>
-              <a:t>▸  Doppelpflege: Daten müssen an zwei Stellen gepflegt werden; eine veraltet.</a:t>
+              <a:t>▸  Das Kernbankverfahren bildet alle Innendienst-Aufgaben ab: Stammdaten, Engagement, Vorgänge, Dokumente, Suche, Auswertungen.</a:t>
             </a:r>
           </a:p>
           <a:p>
@@ -6535,7 +9500,7 @@
                 </a:solidFill>
                 <a:latin typeface="Arial"/>
               </a:rPr>
-              <a:t>▸  Fehlerquelle: Aus widersprüchlichen Ständen entstehen falsche Auskünfte.</a:t>
+              <a:t>▸  Jede Information hat genau einen richtigen Platz im System – nicht auf einem Notizzettel daneben.</a:t>
             </a:r>
           </a:p>
           <a:p>
@@ -6554,45 +9519,7 @@
                 </a:solidFill>
                 <a:latin typeface="Arial"/>
               </a:rPr>
-              <a:t>▸  Datenschutz: Personenbezogene Kundendaten außerhalb des Systems sind ein DSGVO-Risiko (Art. 5 Abs. 1 lit. f und Art. 32 DSGVO ). Konkret heißt das: Eine Excel-Liste mit Kundennamen und Kreditbeträgen auf einem privaten Laufwerk oder einem USB-Stick ist ein Datenschutzverstoß, den Ihre Bank im Prüfungsfall melden müsste. Kundendaten gehören ausschließlich ins System.</a:t>
-            </a:r>
-          </a:p>
-          <a:p>
-            <a:pPr marL="190500" indent="-190500">
-              <a:spcBef>
-                <a:spcPts val="400"/>
-              </a:spcBef>
-              <a:spcAft>
-                <a:spcPts val="200"/>
-              </a:spcAft>
-            </a:pPr>
-            <a:r>
-              <a:rPr sz="1300">
-                <a:solidFill>
-                  <a:srgbClr val="3D5466"/>
-                </a:solidFill>
-                <a:latin typeface="Arial"/>
-              </a:rPr>
-              <a:t>▸  Kein gemeinsamer Stand: Der Berater sieht Ihre Notiz nicht – Wissen geht verloren.</a:t>
-            </a:r>
-          </a:p>
-          <a:p>
-            <a:pPr marL="190500" indent="-190500">
-              <a:spcBef>
-                <a:spcPts val="400"/>
-              </a:spcBef>
-              <a:spcAft>
-                <a:spcPts val="200"/>
-              </a:spcAft>
-            </a:pPr>
-            <a:r>
-              <a:rPr sz="1300">
-                <a:solidFill>
-                  <a:srgbClr val="3D5466"/>
-                </a:solidFill>
-                <a:latin typeface="Arial"/>
-              </a:rPr>
-              <a:t>▸  Die Lösung ist nicht „mehr Disziplin", sondern den Systemweg so zu kennen, dass er der schnellere ist. Genau das üben Sie heute.</a:t>
+              <a:t>▸  Wer im System führt, ist auch bei Urlaub oder Krankheit vertretbar: die Kollegin sieht denselben Stand.</a:t>
             </a:r>
           </a:p>
         </p:txBody>
@@ -6708,7 +9635,7 @@
             <a:avLst/>
           </a:prstGeom>
           <a:solidFill>
-            <a:srgbClr val="EDEDF3"/>
+            <a:srgbClr val="FFFFFF"/>
           </a:solidFill>
           <a:ln>
             <a:noFill/>
@@ -6809,51 +9736,43 @@
                 </a:solidFill>
                 <a:latin typeface="Consolas"/>
               </a:rPr>
-              <a:t>VA03  ·  ARBEITSBLATT</a:t>
-            </a:r>
-          </a:p>
-        </p:txBody>
-      </p:sp>
-      <p:sp>
-        <p:nvSpPr>
-          <p:cNvPr id="5" name="Rectangle 4"/>
-          <p:cNvSpPr/>
-          <p:nvPr/>
-        </p:nvSpPr>
-        <p:spPr>
-          <a:xfrm>
-            <a:off x="0" y="1234440"/>
-            <a:ext cx="12188952" cy="12700"/>
-          </a:xfrm>
-          <a:prstGeom prst="rect">
-            <a:avLst/>
-          </a:prstGeom>
-          <a:solidFill>
-            <a:srgbClr val="D8DFE4"/>
-          </a:solidFill>
-          <a:ln>
-            <a:noFill/>
-          </a:ln>
-        </p:spPr>
-        <p:style>
-          <a:lnRef idx="1">
-            <a:schemeClr val="accent1"/>
-          </a:lnRef>
-          <a:fillRef idx="3">
-            <a:schemeClr val="accent1"/>
-          </a:fillRef>
-          <a:effectRef idx="2">
-            <a:schemeClr val="accent1"/>
-          </a:effectRef>
-          <a:fontRef idx="minor">
-            <a:schemeClr val="lt1"/>
-          </a:fontRef>
-        </p:style>
-        <p:txBody>
-          <a:bodyPr rtlCol="0" anchor="ctr"/>
-          <a:lstStyle/>
-          <a:p>
-            <a:pPr algn="ctr"/>
+              <a:t>VA03  ·  SCHAUBILD</a:t>
+            </a:r>
+          </a:p>
+        </p:txBody>
+      </p:sp>
+      <p:sp>
+        <p:nvSpPr>
+          <p:cNvPr id="5" name="TextBox 4"/>
+          <p:cNvSpPr txBox="1"/>
+          <p:nvPr/>
+        </p:nvSpPr>
+        <p:spPr>
+          <a:xfrm>
+            <a:off x="685800" y="502920"/>
+            <a:ext cx="10817352" cy="594360"/>
+          </a:xfrm>
+          <a:prstGeom prst="rect">
+            <a:avLst/>
+          </a:prstGeom>
+          <a:noFill/>
+        </p:spPr>
+        <p:txBody>
+          <a:bodyPr wrap="square">
+            <a:spAutoFit/>
+          </a:bodyPr>
+          <a:lstStyle/>
+          <a:p>
+            <a:pPr algn="l"/>
+            <a:r>
+              <a:rPr sz="2000" b="1" i="0">
+                <a:solidFill>
+                  <a:srgbClr val="1F2C56"/>
+                </a:solidFill>
+                <a:latin typeface="Arial"/>
+              </a:rPr>
+              <a:t>agree</a:t>
+            </a:r>
           </a:p>
         </p:txBody>
       </p:sp>
@@ -6865,8 +9784,8 @@
         </p:nvSpPr>
         <p:spPr>
           <a:xfrm>
-            <a:off x="685800" y="502920"/>
-            <a:ext cx="36576" cy="658368"/>
+            <a:off x="685800" y="1143000"/>
+            <a:ext cx="10817352" cy="25400"/>
           </a:xfrm>
           <a:prstGeom prst="rect">
             <a:avLst/>
@@ -6900,240 +9819,33 @@
           </a:p>
         </p:txBody>
       </p:sp>
-      <p:sp>
-        <p:nvSpPr>
-          <p:cNvPr id="7" name="TextBox 6"/>
-          <p:cNvSpPr txBox="1"/>
-          <p:nvPr/>
-        </p:nvSpPr>
-        <p:spPr>
-          <a:xfrm>
-            <a:off x="813816" y="502920"/>
-            <a:ext cx="10634472" cy="685800"/>
-          </a:xfrm>
-          <a:prstGeom prst="rect">
-            <a:avLst/>
-          </a:prstGeom>
-          <a:noFill/>
-        </p:spPr>
-        <p:txBody>
-          <a:bodyPr wrap="square">
-            <a:spAutoFit/>
-          </a:bodyPr>
-          <a:lstStyle/>
-          <a:p>
-            <a:pPr algn="l"/>
-            <a:r>
-              <a:rPr sz="2400" b="1" i="0">
-                <a:solidFill>
-                  <a:srgbClr val="1F2C56"/>
-                </a:solidFill>
-                <a:latin typeface="Arial"/>
-              </a:rPr>
-              <a:t>Praxisfall: Ein Vormittag im Innendienst (Metallbau Musterregion GmbH)</a:t>
-            </a:r>
-          </a:p>
-        </p:txBody>
-      </p:sp>
-      <p:sp>
-        <p:nvSpPr>
-          <p:cNvPr id="8" name="TextBox 7"/>
-          <p:cNvSpPr txBox="1"/>
-          <p:nvPr/>
-        </p:nvSpPr>
-        <p:spPr>
-          <a:xfrm>
-            <a:off x="685800" y="1554480"/>
-            <a:ext cx="10817352" cy="3840480"/>
-          </a:xfrm>
-          <a:prstGeom prst="rect">
-            <a:avLst/>
-          </a:prstGeom>
-          <a:noFill/>
-        </p:spPr>
-        <p:txBody>
-          <a:bodyPr wrap="square">
-            <a:spAutoFit/>
-          </a:bodyPr>
-          <a:lstStyle/>
-          <a:p>
-            <a:pPr marL="190500" indent="-190500">
-              <a:spcBef>
-                <a:spcPts val="400"/>
-              </a:spcBef>
-              <a:spcAft>
-                <a:spcPts val="200"/>
-              </a:spcAft>
-            </a:pPr>
-            <a:r>
-              <a:rPr sz="1400">
-                <a:solidFill>
-                  <a:srgbClr val="3D5466"/>
-                </a:solidFill>
-                <a:latin typeface="Arial"/>
-              </a:rPr>
-              <a:t>▸  Ausgangslage (anonymisiert)</a:t>
-            </a:r>
-          </a:p>
-          <a:p>
-            <a:pPr marL="190500" indent="-190500">
-              <a:spcBef>
-                <a:spcPts val="400"/>
-              </a:spcBef>
-              <a:spcAft>
-                <a:spcPts val="200"/>
-              </a:spcAft>
-            </a:pPr>
-            <a:r>
-              <a:rPr sz="1400">
-                <a:solidFill>
-                  <a:srgbClr val="3D5466"/>
-                </a:solidFill>
-                <a:latin typeface="Arial"/>
-              </a:rPr>
-              <a:t>▸  Sie betreuen im Innendienst das Engagement der Metallbau Musterregion GmbH (Hausbank: VR-Bank Musterregion eG). An einem Vormittag laufen drei Vorgänge bei Ihnen auf:</a:t>
-            </a:r>
-          </a:p>
-          <a:p>
-            <a:pPr marL="190500" indent="-190500">
-              <a:spcBef>
-                <a:spcPts val="400"/>
-              </a:spcBef>
-              <a:spcAft>
-                <a:spcPts val="200"/>
-              </a:spcAft>
-            </a:pPr>
-            <a:r>
-              <a:rPr sz="1400">
-                <a:solidFill>
-                  <a:srgbClr val="3D5466"/>
-                </a:solidFill>
-                <a:latin typeface="Arial"/>
-              </a:rPr>
-              <a:t>▸  Die Geschäftsführung hat per E-Mail eine neue Geschäftsadresse mitgeteilt.</a:t>
-            </a:r>
-          </a:p>
-          <a:p>
-            <a:pPr marL="190500" indent="-190500">
-              <a:spcBef>
-                <a:spcPts val="400"/>
-              </a:spcBef>
-              <a:spcAft>
-                <a:spcPts val="200"/>
-              </a:spcAft>
-            </a:pPr>
-            <a:r>
-              <a:rPr sz="1400">
-                <a:solidFill>
-                  <a:srgbClr val="3D5466"/>
-                </a:solidFill>
-                <a:latin typeface="Arial"/>
-              </a:rPr>
-              <a:t>▸  Der Berater fragt telefonisch, ob der aktuelle Sicherheitenvertrag vorliegt.</a:t>
-            </a:r>
-          </a:p>
-          <a:p>
-            <a:pPr marL="190500" indent="-190500">
-              <a:spcBef>
-                <a:spcPts val="400"/>
-              </a:spcBef>
-              <a:spcAft>
-                <a:spcPts val="200"/>
-              </a:spcAft>
-            </a:pPr>
-            <a:r>
-              <a:rPr sz="1400">
-                <a:solidFill>
-                  <a:srgbClr val="3D5466"/>
-                </a:solidFill>
-                <a:latin typeface="Arial"/>
-              </a:rPr>
-              <a:t>▸  Eine BWA wurde zugesagt, ist aber noch nicht eingegangen – das müssen Sie nachhalten.</a:t>
-            </a:r>
-          </a:p>
-        </p:txBody>
-      </p:sp>
-      <p:sp>
-        <p:nvSpPr>
-          <p:cNvPr id="9" name="Rectangle 8"/>
-          <p:cNvSpPr/>
-          <p:nvPr/>
-        </p:nvSpPr>
-        <p:spPr>
-          <a:xfrm>
-            <a:off x="685800" y="5486400"/>
-            <a:ext cx="10817352" cy="640080"/>
-          </a:xfrm>
-          <a:prstGeom prst="rect">
-            <a:avLst/>
-          </a:prstGeom>
-          <a:solidFill>
-            <a:srgbClr val="1F2C56"/>
-          </a:solidFill>
-          <a:ln>
-            <a:noFill/>
-          </a:ln>
-        </p:spPr>
-        <p:style>
-          <a:lnRef idx="1">
-            <a:schemeClr val="accent1"/>
-          </a:lnRef>
-          <a:fillRef idx="3">
-            <a:schemeClr val="accent1"/>
-          </a:fillRef>
-          <a:effectRef idx="2">
-            <a:schemeClr val="accent1"/>
-          </a:effectRef>
-          <a:fontRef idx="minor">
-            <a:schemeClr val="lt1"/>
-          </a:fontRef>
-        </p:style>
-        <p:txBody>
-          <a:bodyPr rtlCol="0" anchor="ctr"/>
-          <a:lstStyle/>
-          <a:p>
-            <a:pPr algn="ctr"/>
-          </a:p>
-        </p:txBody>
-      </p:sp>
-      <p:sp>
-        <p:nvSpPr>
-          <p:cNvPr id="10" name="TextBox 9"/>
-          <p:cNvSpPr txBox="1"/>
-          <p:nvPr/>
-        </p:nvSpPr>
-        <p:spPr>
-          <a:xfrm>
-            <a:off x="868680" y="5596128"/>
-            <a:ext cx="10451592" cy="457200"/>
-          </a:xfrm>
-          <a:prstGeom prst="rect">
-            <a:avLst/>
-          </a:prstGeom>
-          <a:noFill/>
-        </p:spPr>
-        <p:txBody>
-          <a:bodyPr wrap="square">
-            <a:spAutoFit/>
-          </a:bodyPr>
-          <a:lstStyle/>
-          <a:p>
-            <a:pPr algn="l"/>
-            <a:r>
-              <a:rPr sz="1300" b="1" i="0">
-                <a:solidFill>
-                  <a:srgbClr val="FFFFFF"/>
-                </a:solidFill>
-                <a:latin typeface="Arial"/>
-              </a:rPr>
-              <a:t>→  Bearbeitung im Teilnehmer-Workbook (Arbeitsblatt mit Ausfüllfeldern)</a:t>
-            </a:r>
-          </a:p>
-        </p:txBody>
-      </p:sp>
-      <p:sp>
-        <p:nvSpPr>
-          <p:cNvPr id="11" name="Rectangle 10"/>
+      <p:pic>
+        <p:nvPicPr>
+          <p:cNvPr id="7" name="Picture 6" descr="image.png"/>
+          <p:cNvPicPr>
+            <a:picLocks noChangeAspect="1"/>
+          </p:cNvPicPr>
+          <p:nvPr/>
+        </p:nvPicPr>
+        <p:blipFill>
+          <a:blip r:embed="rId2"/>
+          <a:stretch>
+            <a:fillRect/>
+          </a:stretch>
+        </p:blipFill>
+        <p:spPr>
+          <a:xfrm>
+            <a:off x="2009463" y="1325880"/>
+            <a:ext cx="8170026" cy="4937760"/>
+          </a:xfrm>
+          <a:prstGeom prst="rect">
+            <a:avLst/>
+          </a:prstGeom>
+        </p:spPr>
+      </p:pic>
+      <p:sp>
+        <p:nvSpPr>
+          <p:cNvPr id="8" name="Rectangle 7"/>
           <p:cNvSpPr/>
           <p:nvPr/>
         </p:nvSpPr>
@@ -7176,7 +9888,7 @@
       </p:sp>
       <p:sp>
         <p:nvSpPr>
-          <p:cNvPr id="12" name="TextBox 11"/>
+          <p:cNvPr id="9" name="TextBox 8"/>
           <p:cNvSpPr txBox="1"/>
           <p:nvPr/>
         </p:nvSpPr>
@@ -7205,6 +9917,41 @@
                 <a:latin typeface="Consolas"/>
               </a:rPr>
               <a:t>FKB Campus  ·  VA03</a:t>
+            </a:r>
+          </a:p>
+        </p:txBody>
+      </p:sp>
+      <p:sp>
+        <p:nvSpPr>
+          <p:cNvPr id="10" name="TextBox 9"/>
+          <p:cNvSpPr txBox="1"/>
+          <p:nvPr/>
+        </p:nvSpPr>
+        <p:spPr>
+          <a:xfrm>
+            <a:off x="7176211" y="6583680"/>
+            <a:ext cx="4326940" cy="256032"/>
+          </a:xfrm>
+          <a:prstGeom prst="rect">
+            <a:avLst/>
+          </a:prstGeom>
+          <a:noFill/>
+        </p:spPr>
+        <p:txBody>
+          <a:bodyPr wrap="none">
+            <a:spAutoFit/>
+          </a:bodyPr>
+          <a:lstStyle/>
+          <a:p>
+            <a:pPr algn="r"/>
+            <a:r>
+              <a:rPr sz="700">
+                <a:solidFill>
+                  <a:srgbClr val="A0B4D2"/>
+                </a:solidFill>
+                <a:latin typeface="Consolas"/>
+              </a:rPr>
+              <a:t>Schaubild</a:t>
             </a:r>
           </a:p>
         </p:txBody>
@@ -7242,6 +9989,250 @@
             <a:avLst/>
           </a:prstGeom>
           <a:solidFill>
+            <a:srgbClr val="1F2C56"/>
+          </a:solidFill>
+          <a:ln>
+            <a:noFill/>
+          </a:ln>
+        </p:spPr>
+        <p:style>
+          <a:lnRef idx="1">
+            <a:schemeClr val="accent1"/>
+          </a:lnRef>
+          <a:fillRef idx="3">
+            <a:schemeClr val="accent1"/>
+          </a:fillRef>
+          <a:effectRef idx="2">
+            <a:schemeClr val="accent1"/>
+          </a:effectRef>
+          <a:fontRef idx="minor">
+            <a:schemeClr val="lt1"/>
+          </a:fontRef>
+        </p:style>
+        <p:txBody>
+          <a:bodyPr rtlCol="0" anchor="ctr"/>
+          <a:lstStyle/>
+          <a:p>
+            <a:pPr algn="ctr"/>
+          </a:p>
+        </p:txBody>
+      </p:sp>
+      <p:sp>
+        <p:nvSpPr>
+          <p:cNvPr id="3" name="TextBox 2"/>
+          <p:cNvSpPr txBox="1"/>
+          <p:nvPr/>
+        </p:nvSpPr>
+        <p:spPr>
+          <a:xfrm>
+            <a:off x="685800" y="2377440"/>
+            <a:ext cx="10817352" cy="365760"/>
+          </a:xfrm>
+          <a:prstGeom prst="rect">
+            <a:avLst/>
+          </a:prstGeom>
+          <a:noFill/>
+        </p:spPr>
+        <p:txBody>
+          <a:bodyPr wrap="none">
+            <a:spAutoFit/>
+          </a:bodyPr>
+          <a:lstStyle/>
+          <a:p>
+            <a:pPr algn="l"/>
+            <a:r>
+              <a:rPr sz="1200">
+                <a:solidFill>
+                  <a:srgbClr val="D9C089"/>
+                </a:solidFill>
+                <a:latin typeface="Consolas"/>
+              </a:rPr>
+              <a:t>00:20–00:30</a:t>
+            </a:r>
+          </a:p>
+        </p:txBody>
+      </p:sp>
+      <p:sp>
+        <p:nvSpPr>
+          <p:cNvPr id="4" name="Rectangle 3"/>
+          <p:cNvSpPr/>
+          <p:nvPr/>
+        </p:nvSpPr>
+        <p:spPr>
+          <a:xfrm>
+            <a:off x="685800" y="2788920"/>
+            <a:ext cx="548640" cy="38100"/>
+          </a:xfrm>
+          <a:prstGeom prst="rect">
+            <a:avLst/>
+          </a:prstGeom>
+          <a:solidFill>
+            <a:srgbClr val="D9C089"/>
+          </a:solidFill>
+          <a:ln>
+            <a:noFill/>
+          </a:ln>
+        </p:spPr>
+        <p:style>
+          <a:lnRef idx="1">
+            <a:schemeClr val="accent1"/>
+          </a:lnRef>
+          <a:fillRef idx="3">
+            <a:schemeClr val="accent1"/>
+          </a:fillRef>
+          <a:effectRef idx="2">
+            <a:schemeClr val="accent1"/>
+          </a:effectRef>
+          <a:fontRef idx="minor">
+            <a:schemeClr val="lt1"/>
+          </a:fontRef>
+        </p:style>
+        <p:txBody>
+          <a:bodyPr rtlCol="0" anchor="ctr"/>
+          <a:lstStyle/>
+          <a:p>
+            <a:pPr algn="ctr"/>
+          </a:p>
+        </p:txBody>
+      </p:sp>
+      <p:sp>
+        <p:nvSpPr>
+          <p:cNvPr id="5" name="TextBox 4"/>
+          <p:cNvSpPr txBox="1"/>
+          <p:nvPr/>
+        </p:nvSpPr>
+        <p:spPr>
+          <a:xfrm>
+            <a:off x="685800" y="3017520"/>
+            <a:ext cx="10817352" cy="1463040"/>
+          </a:xfrm>
+          <a:prstGeom prst="rect">
+            <a:avLst/>
+          </a:prstGeom>
+          <a:noFill/>
+        </p:spPr>
+        <p:txBody>
+          <a:bodyPr wrap="square">
+            <a:spAutoFit/>
+          </a:bodyPr>
+          <a:lstStyle/>
+          <a:p>
+            <a:pPr algn="l"/>
+            <a:r>
+              <a:rPr sz="4000" b="1" i="0">
+                <a:solidFill>
+                  <a:srgbClr val="FFFFFF"/>
+                </a:solidFill>
+                <a:latin typeface="Arial"/>
+              </a:rPr>
+              <a:t>Theorie-Input 2</a:t>
+            </a:r>
+          </a:p>
+        </p:txBody>
+      </p:sp>
+      <p:sp>
+        <p:nvSpPr>
+          <p:cNvPr id="6" name="TextBox 5"/>
+          <p:cNvSpPr txBox="1"/>
+          <p:nvPr/>
+        </p:nvSpPr>
+        <p:spPr>
+          <a:xfrm>
+            <a:off x="685800" y="4480560"/>
+            <a:ext cx="8653881" cy="1280160"/>
+          </a:xfrm>
+          <a:prstGeom prst="rect">
+            <a:avLst/>
+          </a:prstGeom>
+          <a:noFill/>
+        </p:spPr>
+        <p:txBody>
+          <a:bodyPr wrap="square">
+            <a:spAutoFit/>
+          </a:bodyPr>
+          <a:lstStyle/>
+          <a:p>
+            <a:pPr algn="l"/>
+            <a:r>
+              <a:rPr sz="1600" b="0" i="0">
+                <a:solidFill>
+                  <a:srgbClr val="C8D2E6"/>
+                </a:solidFill>
+                <a:latin typeface="Arial"/>
+              </a:rPr>
+              <a:t>Verstehen, warum Workarounds entstehen – und was sie wirklich kosten.</a:t>
+            </a:r>
+          </a:p>
+        </p:txBody>
+      </p:sp>
+      <p:sp>
+        <p:nvSpPr>
+          <p:cNvPr id="7" name="TextBox 6"/>
+          <p:cNvSpPr txBox="1"/>
+          <p:nvPr/>
+        </p:nvSpPr>
+        <p:spPr>
+          <a:xfrm>
+            <a:off x="685800" y="6355080"/>
+            <a:ext cx="10817352" cy="274320"/>
+          </a:xfrm>
+          <a:prstGeom prst="rect">
+            <a:avLst/>
+          </a:prstGeom>
+          <a:noFill/>
+        </p:spPr>
+        <p:txBody>
+          <a:bodyPr wrap="none">
+            <a:spAutoFit/>
+          </a:bodyPr>
+          <a:lstStyle/>
+          <a:p>
+            <a:pPr algn="l"/>
+            <a:r>
+              <a:rPr sz="700">
+                <a:solidFill>
+                  <a:srgbClr val="8CA0C3"/>
+                </a:solidFill>
+                <a:latin typeface="Consolas"/>
+              </a:rPr>
+              <a:t>FKB Campus  ·  VA03</a:t>
+            </a:r>
+          </a:p>
+        </p:txBody>
+      </p:sp>
+    </p:spTree>
+  </p:cSld>
+  <p:clrMapOvr>
+    <a:masterClrMapping/>
+  </p:clrMapOvr>
+</p:sld>
+</file>
+
+<file path=ppt/slides/slide9.xml><?xml version="1.0" encoding="utf-8"?>
+<p:sld xmlns:a="http://schemas.openxmlformats.org/drawingml/2006/main" xmlns:p="http://schemas.openxmlformats.org/presentationml/2006/main" xmlns:r="http://schemas.openxmlformats.org/officeDocument/2006/relationships">
+  <p:cSld>
+    <p:spTree>
+      <p:nvGrpSpPr>
+        <p:cNvPr id="1" name=""/>
+        <p:cNvGrpSpPr/>
+        <p:nvPr/>
+      </p:nvGrpSpPr>
+      <p:grpSpPr/>
+      <p:sp>
+        <p:nvSpPr>
+          <p:cNvPr id="2" name="Rectangle 1"/>
+          <p:cNvSpPr/>
+          <p:nvPr/>
+        </p:nvSpPr>
+        <p:spPr>
+          <a:xfrm>
+            <a:off x="0" y="0"/>
+            <a:ext cx="12188952" cy="6858000"/>
+          </a:xfrm>
+          <a:prstGeom prst="rect">
+            <a:avLst/>
+          </a:prstGeom>
+          <a:solidFill>
             <a:srgbClr val="EDEDF3"/>
           </a:solidFill>
           <a:ln>
@@ -7464,7 +10455,7 @@
                 </a:solidFill>
                 <a:latin typeface="Arial"/>
               </a:rPr>
-              <a:t>Reflexionsfragen</a:t>
+              <a:t>Warum Workarounds entstehen</a:t>
             </a:r>
           </a:p>
         </p:txBody>
@@ -7486,10 +10477,48 @@
           <a:noFill/>
         </p:spPr>
         <p:txBody>
-          <a:bodyPr wrap="square" anchor="ctr">
+          <a:bodyPr wrap="square">
             <a:spAutoFit/>
           </a:bodyPr>
           <a:lstStyle/>
+          <a:p>
+            <a:pPr marL="177800" indent="-177800">
+              <a:spcBef>
+                <a:spcPts val="600"/>
+              </a:spcBef>
+              <a:spcAft>
+                <a:spcPts val="200"/>
+              </a:spcAft>
+            </a:pPr>
+            <a:r>
+              <a:rPr sz="1200" i="1">
+                <a:solidFill>
+                  <a:srgbClr val="3D5466"/>
+                </a:solidFill>
+                <a:latin typeface="Arial"/>
+              </a:rPr>
+              <a:t>→  Ein System wird genutzt, wenn es nützlich und bedienbar ist (Davis, 1989). Ein Workaround ist ein Signal, kein Charakterfehler.</a:t>
+            </a:r>
+          </a:p>
+          <a:p>
+            <a:pPr>
+              <a:spcBef>
+                <a:spcPts val="1000"/>
+              </a:spcBef>
+              <a:spcAft>
+                <a:spcPts val="200"/>
+              </a:spcAft>
+            </a:pPr>
+            <a:r>
+              <a:rPr sz="800" b="1">
+                <a:solidFill>
+                  <a:srgbClr val="78808C"/>
+                </a:solidFill>
+                <a:latin typeface="Consolas"/>
+              </a:rPr>
+              <a:t>DIE VIER VERSTECKTEN KOSTEN EINER PARALLELLISTE</a:t>
+            </a:r>
+          </a:p>
           <a:p>
             <a:pPr marL="190500" indent="-190500">
               <a:spcBef>
@@ -7506,7 +10535,7 @@
                 </a:solidFill>
                 <a:latin typeface="Arial"/>
               </a:rPr>
-              <a:t>▸  Welcher Workaround kostet Sie persönlich am meisten Zeit – und was hält Sie vom Systemweg ab?</a:t>
+              <a:t>▸  Doppelpflege – dieselben Daten an zwei Stellen; eine veraltet.</a:t>
             </a:r>
           </a:p>
           <a:p>
@@ -7525,7 +10554,7 @@
                 </a:solidFill>
                 <a:latin typeface="Arial"/>
               </a:rPr>
-              <a:t>▸  Woran merken Sie, dass eine Information „nur in Ihrem Kopf" und nicht im System steht?</a:t>
+              <a:t>▸  Fehlerquelle – aus widersprüchlichen Ständen entstehen falsche Auskünfte.</a:t>
             </a:r>
           </a:p>
           <a:p>
@@ -7544,7 +10573,26 @@
                 </a:solidFill>
                 <a:latin typeface="Arial"/>
               </a:rPr>
-              <a:t>▸  Wie würden Sie einer neuen Kollegin in einem Satz erklären, warum alles in agree gehört?</a:t>
+              <a:t>▸  Datenschutz – Kundendaten außerhalb des Systems sind ein DSGVO-Risiko (Art. 5, 32 DSGVO).</a:t>
+            </a:r>
+          </a:p>
+          <a:p>
+            <a:pPr marL="190500" indent="-190500">
+              <a:spcBef>
+                <a:spcPts val="400"/>
+              </a:spcBef>
+              <a:spcAft>
+                <a:spcPts val="200"/>
+              </a:spcAft>
+            </a:pPr>
+            <a:r>
+              <a:rPr sz="1300">
+                <a:solidFill>
+                  <a:srgbClr val="3D5466"/>
+                </a:solidFill>
+                <a:latin typeface="Arial"/>
+              </a:rPr>
+              <a:t>▸  Kein gemeinsamer Stand – der Berater sieht die Notiz nicht, Wissen geht verloren.</a:t>
             </a:r>
           </a:p>
         </p:txBody>

</xml_diff>